<commit_message>
Néerlandais 2: apply review of session 1
Page order aligned with the booklet, more natural Dutch in model answers,
work modalities added, booklet typos flagged in speaker notes.

Co-Authored-By: Claude Opus 5.5 <noreply@anthropic.com>
Claude-Session: https://claude.ai/code/session_01MyRQMehgXGGdXneVX6jxb4
</commit_message>
<xml_diff>
--- a/neerlandais2/powerpoints/Seance_01_Kennismaking_Goedemorgen.pptx
+++ b/neerlandais2/powerpoints/Seance_01_Kennismaking_Goedemorgen.pptx
@@ -132,7 +132,7 @@
   <p:extLst>
     <p:ext uri="{521415D9-36F7-43E2-AB2F-B90AF26B5E84}">
       <p14:sectionLst xmlns:p14="http://schemas.microsoft.com/office/powerpoint/2010/main">
-        <p14:section name="Ouverture" id="{6319551e-b386-a1de-72a7-b9c784061d91}">
+        <p14:section name="Ouverture" id="{e15c983a-42c5-ad6a-50a4-8877b2daf541}">
           <p14:sldIdLst>
             <p14:sldId id="256"/>
             <p14:sldId id="257"/>
@@ -161,7 +161,7 @@
             <p14:sldId id="280"/>
           </p14:sldIdLst>
         </p14:section>
-        <p14:section name="Clôture" id="{bb2ba078-24a6-b799-183d-c93818532f9a}">
+        <p14:section name="Clôture" id="{d5b94644-9380-ac4d-fe94-54d00d3b6dc3}">
           <p14:sldIdLst>
             <p14:sldId id="281"/>
           </p14:sldIdLst>
@@ -658,7 +658,7 @@
           <a:p>
             <a:r>
               <a:rPr lang="en-US" dirty="0"/>
-              <a:t>Exercice ajouté pour vérifier la compréhension globale avant d’entrer dans la séquence 1.1.</a:t>
+              <a:t>Exercice ajouté pour vérifier la compréhension globale avant d’entrer dans la séquence 1.1. Phrase 2 : « wel » contredit une phrase négative (Hij heeft geen tijd. — Jawel, hij heeft wel tijd!). Phrase 4 : accepter aussi « Emma heeft geen tijd, haar les begint zo ».</a:t>
             </a:r>
             <a:endParaRPr lang="en-US" dirty="0"/>
           </a:p>
@@ -834,7 +834,7 @@
           <a:p>
             <a:r>
               <a:rPr lang="en-US" dirty="0"/>
-              <a:t>Coquilles du zinnenbouwer 1.1 à signaler aux étudiants : famille B « werk Emma » → werkt Emma ; « Overmorgen » (après-demain) est sans doute « Overdag » (pendant la journée). Famille C : avec les verbes séparables, la particule va à la fin : « Om zeven uur sta ik elke dag op ».</a:t>
+              <a:t>Coquilles du zinnenbouwer 1.1 à signaler aux étudiants : famille B « werk Emma » → werkt Emma ; « Overmorgen » (après-demain) est sans doute « Overdag » (pendant la journée). Famille C : avec les verbes séparables, la particule va à la fin : « Om zeven uur sta ik elke dag op » (et non « sta ik op elke dag »). Famille B : « heb ik / heeft Sarah / hebben wij » + un lieu donne une phrase incomplète (hebben demande un complément d’objet). Famille E : éviter « Deze week is het maandag » et les temps incohérents (« Gisteren wordt het… ») : toutes les combinaisons ne sont pas correctes.</a:t>
             </a:r>
             <a:endParaRPr lang="en-US" dirty="0"/>
           </a:p>
@@ -922,7 +922,7 @@
           <a:p>
             <a:r>
               <a:rPr lang="en-US" dirty="0"/>
-              <a:t>Aperçu de l’inversion, traitée en détail à la séance 2 avec la fiche de grammaire A2-01. Ici, il suffit de faire remarquer la 2e position du verbe.</a:t>
+              <a:t>Aperçu de l’inversion, traitée en détail à la séance 2 avec la fiche de grammaire A2-01. Ici, il suffit de faire remarquer la 2e position du verbe. Familles A à D = celles de l’exercice 1.1.3. Famille E à l’oral : « Morgen is het zaterdag » (het après le verbe).</a:t>
             </a:r>
             <a:endParaRPr lang="en-US" dirty="0"/>
           </a:p>
@@ -1010,7 +1010,7 @@
           <a:p>
             <a:r>
               <a:rPr lang="en-US" dirty="0"/>
-              <a:t>Lire le tableau ligne par ligne, faire répéter en chœur. Attirer l’attention sur ’s (prononcé [s] et collé au mot : « smorgens »), traité au Klankmoment de la séance 2. « Vannacht » peut désigner la nuit passée ou la nuit qui vient.</a:t>
+              <a:t>Lire le tableau ligne par ligne, faire répéter en chœur. Attirer l’attention sur ’s (prononcé [s] et collé au mot : « smorgens »), traité au Klankmoment de la séance 2. « Vannacht » peut désigner la nuit passée ou la nuit qui vient. ’s ochtends / vanochtend (zinnenbouwer, famille A) = ’s morgens / vanmorgen, très courant en Belgique. Nuance d’usage : « Goedenacht! » et « Welterusten! » servent surtout à prendre congé tard le soir ou avant de dormir ; pour saluer quelqu’un qu’on rencontre à 23 h, on dit plutôt « Goedenavond! ».</a:t>
             </a:r>
             <a:endParaRPr lang="en-US" dirty="0"/>
           </a:p>
@@ -1098,7 +1098,7 @@
           <a:p>
             <a:r>
               <a:rPr lang="en-US" dirty="0"/>
-              <a:t>Faire produire une phrase par carte avec « avond » : Goedenavond! / ’s Avonds kijk ik tv. / Vanavond ga ik naar de cursus. / In de avond is het rustig.</a:t>
+              <a:t>Le livret illustre l’usage ④ avec « In de morgen is het rustig » ; la carte reprend « middag » pour comparer les quatre formes d’un même moment. Faire produire une phrase par carte avec « avond » : Goedenavond! / ’s Avonds kijk ik tv. / Vanavond ga ik naar de cursus. / In de avond is het rustig.</a:t>
             </a:r>
             <a:endParaRPr lang="en-US" dirty="0"/>
           </a:p>
@@ -1274,7 +1274,7 @@
           <a:p>
             <a:r>
               <a:rPr lang="en-US" dirty="0"/>
-              <a:t>Grille projetée pour la mise en commun. Coquille du livret : « Morgens werk ik op school » → « ’s Morgens werk ik op school » (ou « ’s Ochtends »). Le livret annonce 10 phrases à numéroter pour 12 phrases proposées : les 2 phrases restantes sont les intrus.</a:t>
+              <a:t>Grille projetée pour la mise en commun. Coquille du livret : « Morgens werk ik op school » → corrigé ici en « ’s Morgens werk ik op school » (« morgens » sans ’s existe en langue familière, mais le cours écrit ’s morgens). Le livret annonce 10 phrases à numéroter pour 12 phrases proposées : les 2 phrases restantes sont les intrus.</a:t>
             </a:r>
             <a:endParaRPr lang="en-US" dirty="0"/>
           </a:p>
@@ -1538,7 +1538,7 @@
           <a:p>
             <a:r>
               <a:rPr lang="en-US" dirty="0"/>
-              <a:t>Durées indicatives sur 90 minutes. La séance couvre les pages ii à 9 du livret ; 1.1.5 à 1.1.7 seront traités à la séance 2.</a:t>
+              <a:t>Durées indicatives sur 90 minutes. La séance couvre les pages ii à 9 du livret ; 1.1.5 à 1.1.7 seront traités à la séance 2. Le livret prévoit 20 min pour 1.1.3 et 15 min pour 1.1.4 : ici on les raccourcit, et 1.1.3 se termine à la maison (voir devoirs).</a:t>
             </a:r>
             <a:endParaRPr lang="en-US" dirty="0"/>
           </a:p>
@@ -1626,7 +1626,7 @@
           <a:p>
             <a:r>
               <a:rPr lang="en-US" dirty="0"/>
-              <a:t>Production libre : pas de correction unique. Passer dans les rangs et vérifier la 2e position du verbe. Le livret dit d’interroger le voisin avec la « famille E » ; dans le zinnenbouwer 1.1, la famille E est celle des jours de la semaine : utiliser simplement la question inversée (Werk jij ook…?).</a:t>
+              <a:t>Production libre : pas de correction unique. Passer dans les rangs et vérifier la 2e position du verbe. Le livret dit d’interroger le voisin avec la « famille E » ; dans le zinnenbouwer 1.1, la famille E est celle des jours de la semaine : utiliser simplement la question inversée (Werk jij ook…?). Les exemples n’utilisent que des blocs du zinnenbouwer (règle de vérification du livret) ; avec un verbe séparable, la particule va à la fin (sta ik elke dag op).</a:t>
             </a:r>
             <a:endParaRPr lang="en-US" dirty="0"/>
           </a:p>
@@ -1890,7 +1890,7 @@
           <a:p>
             <a:r>
               <a:rPr lang="en-US" dirty="0"/>
-              <a:t>Accepter les réponses courtes ; à l’oral, exiger la phrase complète avec inversion.</a:t>
+              <a:t>Accepter les réponses courtes ; à l’oral, exiger la phrase complète avec inversion (’s Morgens zeg ik «Goedemorgen!»). Ligne 4 : le livret classe Goedenacht/Welterusten dans « nuit » ; préciser qu’on les dit surtout en partant ou avant de dormir.</a:t>
             </a:r>
             <a:endParaRPr lang="en-US" dirty="0"/>
           </a:p>
@@ -2330,7 +2330,7 @@
           <a:p>
             <a:r>
               <a:rPr lang="en-US" dirty="0"/>
-              <a:t>Faire feuilleter le livret et retrouver chaque type d’encadré. Le tag « + BONUS » signale les exercices de ces diapositives qui ne figurent pas dans le syllabus.</a:t>
+              <a:t>Le mot « palier » (= niveau) vient du livret. Montrer que chaque séquence correspond à un extrait du dialogue d’ouverture.</a:t>
             </a:r>
             <a:endParaRPr lang="en-US" dirty="0"/>
           </a:p>
@@ -2418,7 +2418,7 @@
           <a:p>
             <a:r>
               <a:rPr lang="en-US" dirty="0"/>
-              <a:t>Le mot « palier » (= niveau) vient du livret. Montrer que chaque séquence correspond à un extrait du dialogue d’ouverture.</a:t>
+              <a:t>Faire feuilleter le livret et retrouver chaque type d’encadré. Le tag « + BONUS » signale les exercices de ces diapositives qui ne figurent pas dans le syllabus.</a:t>
             </a:r>
             <a:endParaRPr lang="en-US" dirty="0"/>
           </a:p>
@@ -2506,7 +2506,7 @@
           <a:p>
             <a:r>
               <a:rPr lang="en-US" dirty="0"/>
-              <a:t>Lire les cartes à voix haute ; faire répéter les noms de villes (Bergen = Mons, Gent = Gand). Le livret écrit « zij helpt hem in het Frans » : plus idiomatique, « zij helpt hem met zijn Frans ».</a:t>
+              <a:t>Bulles de l’image : « Ben je klaar voor de cursus? » / « Zeker weten! » / « Ik heb mijn boek al bij me. » Faire des hypothèses en français, puis passer au dialogue.</a:t>
             </a:r>
             <a:endParaRPr lang="en-US" dirty="0"/>
           </a:p>
@@ -2594,7 +2594,7 @@
           <a:p>
             <a:r>
               <a:rPr lang="en-US" dirty="0"/>
-              <a:t>Bulles de l’image : « Ben je klaar voor de cursus? » / « Zeker weten! » / « Ik heb mijn boek al bij me. » Faire des hypothèses en français, puis passer au dialogue.</a:t>
+              <a:t>Lire les cartes à voix haute ; faire répéter les noms de villes (Bergen = Mons, Gent = Gand). Le livret écrit « zij helpt hem in het Frans » : plus idiomatique, « zij helpt hem met zijn Frans » (version utilisée sur la diapositive). Titre de la planche : « De personages van het palier » — « palier » est un mot français ; en néerlandais : « van dit niveau ».</a:t>
             </a:r>
             <a:endParaRPr lang="en-US" dirty="0"/>
           </a:p>
@@ -2682,7 +2682,7 @@
           <a:p>
             <a:r>
               <a:rPr lang="en-US" dirty="0"/>
-              <a:t>Première lecture par le professeur, deuxième lecture en binôme (Emma / Pieter), puis on inverse. Coquille du livret : « Dag Pieter!! » (double point d’exclamation). Les lignes ne sont pas numérotées dans le livret ; la numérotation ci-contre sert au tableau.</a:t>
+              <a:t>Première lecture par le professeur, deuxième lecture en binôme (Emma / Pieter), puis on inverse. Coquille du livret : « Dag Pieter!! » (double point d’exclamation). Les lignes ne sont pas numérotées dans le livret ; la numérotation ci-contre (une ligne = une réplique) reprend celle des « Focus » du livret : 1–2 (p. 4), 2–4 (p. 19), 5–7 (p. 35). Ben/heb apparaissent déjà aux lignes 3–4. Pour la séquence 1.4, le livret (p. 51) annonce « lignes 7–9 » mais cite d’autres répliques (« Dag, Pieter! Tot snel! ») : dans ce dialogue, le congé est aux lignes 8–9.</a:t>
             </a:r>
             <a:endParaRPr lang="en-US" dirty="0"/>
           </a:p>
@@ -2770,7 +2770,7 @@
           <a:p>
             <a:r>
               <a:rPr lang="en-US" dirty="0"/>
-              <a:t>Exercice ajouté pour vérifier la compréhension globale avant d’entrer dans la séquence 1.1.</a:t>
+              <a:t>Exercice ajouté pour vérifier la compréhension globale avant d’entrer dans la séquence 1.1. Phrase 2 : « wel » contredit une phrase négative (Hij heeft geen tijd. — Jawel, hij heeft wel tijd!). Phrase 4 : accepter aussi « Emma heeft geen tijd, haar les begint zo ».</a:t>
             </a:r>
             <a:endParaRPr lang="en-US" dirty="0"/>
           </a:p>
@@ -4162,7 +4162,7 @@
                   <a:schemeClr val="accent3"/>
                 </a:solidFill>
               </a:rPr>
-              <a:t>niet waar: Pieter heeft vandaag tijd.</a:t>
+              <a:t>niet waar: Pieter heeft vandaag wel tijd.</a:t>
             </a:r>
             <a:endParaRPr lang="en-US" sz="2400" dirty="0"/>
           </a:p>
@@ -4286,7 +4286,7 @@
                   <a:schemeClr val="tx1"/>
                 </a:solidFill>
               </a:rPr>
-              <a:t>Ze zeggen «Tot morgen!». → </a:t>
+              <a:t>Ze zeggen «Tot morgen!» → </a:t>
             </a:r>
             <a:r>
               <a:rPr lang="en-US" sz="2400" b="1" dirty="0">
@@ -4294,7 +4294,7 @@
                   <a:schemeClr val="accent3"/>
                 </a:solidFill>
               </a:rPr>
-              <a:t>niet waar: ze zeggen «Tot straks!».</a:t>
+              <a:t>niet waar: ze zeggen «Tot straks!»</a:t>
             </a:r>
             <a:endParaRPr lang="en-US" sz="2400" dirty="0"/>
           </a:p>
@@ -7453,7 +7453,7 @@
                   <a:schemeClr val="accent5"/>
                 </a:solidFill>
               </a:rPr>
-              <a:t>Famille E</a:t>
+              <a:t>Famille D</a:t>
             </a:r>
             <a:endParaRPr lang="en-US" sz="1400" dirty="0"/>
           </a:p>
@@ -7468,7 +7468,7 @@
         <p:spPr>
           <a:xfrm>
             <a:off x="2103120" y="4510278"/>
-            <a:ext cx="963168" cy="219456"/>
+            <a:ext cx="1280160" cy="219456"/>
           </a:xfrm>
           <a:prstGeom prst="rect">
             <a:avLst/>
@@ -7504,7 +7504,7 @@
         <p:spPr>
           <a:xfrm>
             <a:off x="2103120" y="4748022"/>
-            <a:ext cx="963168" cy="329184"/>
+            <a:ext cx="1280160" cy="329184"/>
           </a:xfrm>
           <a:prstGeom prst="roundRect">
             <a:avLst>
@@ -7533,7 +7533,7 @@
         <p:spPr>
           <a:xfrm>
             <a:off x="2139696" y="4748022"/>
-            <a:ext cx="890016" cy="329184"/>
+            <a:ext cx="1207008" cy="329184"/>
           </a:xfrm>
           <a:prstGeom prst="rect">
             <a:avLst/>
@@ -7554,7 +7554,7 @@
                   <a:schemeClr val="bg1"/>
                 </a:solidFill>
               </a:rPr>
-              <a:t>Morgen</a:t>
+              <a:t>Na de les</a:t>
             </a:r>
             <a:endParaRPr lang="en-US" sz="1600" dirty="0"/>
           </a:p>
@@ -7568,7 +7568,7 @@
         </p:nvSpPr>
         <p:spPr>
           <a:xfrm>
-            <a:off x="3176016" y="4510278"/>
+            <a:off x="3493008" y="4510278"/>
             <a:ext cx="685800" cy="219456"/>
           </a:xfrm>
           <a:prstGeom prst="rect">
@@ -7604,7 +7604,7 @@
         </p:nvSpPr>
         <p:spPr>
           <a:xfrm>
-            <a:off x="3176016" y="4748022"/>
+            <a:off x="3493008" y="4748022"/>
             <a:ext cx="685800" cy="329184"/>
           </a:xfrm>
           <a:prstGeom prst="roundRect">
@@ -7633,7 +7633,7 @@
         </p:nvSpPr>
         <p:spPr>
           <a:xfrm>
-            <a:off x="3212592" y="4748022"/>
+            <a:off x="3529584" y="4748022"/>
             <a:ext cx="612648" cy="329184"/>
           </a:xfrm>
           <a:prstGeom prst="rect">
@@ -7655,7 +7655,7 @@
                   <a:schemeClr val="bg1"/>
                 </a:solidFill>
               </a:rPr>
-              <a:t>is</a:t>
+              <a:t>zeg</a:t>
             </a:r>
             <a:endParaRPr lang="en-US" sz="1600" dirty="0"/>
           </a:p>
@@ -7669,7 +7669,7 @@
         </p:nvSpPr>
         <p:spPr>
           <a:xfrm>
-            <a:off x="3971544" y="4510278"/>
+            <a:off x="4288536" y="4510278"/>
             <a:ext cx="685800" cy="219456"/>
           </a:xfrm>
           <a:prstGeom prst="rect">
@@ -7705,7 +7705,7 @@
         </p:nvSpPr>
         <p:spPr>
           <a:xfrm>
-            <a:off x="3971544" y="4748022"/>
+            <a:off x="4288536" y="4748022"/>
             <a:ext cx="685800" cy="329184"/>
           </a:xfrm>
           <a:prstGeom prst="roundRect">
@@ -7734,7 +7734,7 @@
         </p:nvSpPr>
         <p:spPr>
           <a:xfrm>
-            <a:off x="4008120" y="4748022"/>
+            <a:off x="4325112" y="4748022"/>
             <a:ext cx="612648" cy="329184"/>
           </a:xfrm>
           <a:prstGeom prst="rect">
@@ -7756,7 +7756,7 @@
                   <a:schemeClr val="bg1"/>
                 </a:solidFill>
               </a:rPr>
-              <a:t>het</a:t>
+              <a:t>ik</a:t>
             </a:r>
             <a:endParaRPr lang="en-US" sz="1600" dirty="0"/>
           </a:p>
@@ -7770,8 +7770,8 @@
         </p:nvSpPr>
         <p:spPr>
           <a:xfrm>
-            <a:off x="4767072" y="4510278"/>
-            <a:ext cx="1174496" cy="219456"/>
+            <a:off x="5084064" y="4510278"/>
+            <a:ext cx="1702816" cy="219456"/>
           </a:xfrm>
           <a:prstGeom prst="rect">
             <a:avLst/>
@@ -7806,8 +7806,8 @@
         </p:nvSpPr>
         <p:spPr>
           <a:xfrm>
-            <a:off x="4767072" y="4748022"/>
-            <a:ext cx="1174496" cy="329184"/>
+            <a:off x="5084064" y="4748022"/>
+            <a:ext cx="1702816" cy="329184"/>
           </a:xfrm>
           <a:prstGeom prst="roundRect">
             <a:avLst>
@@ -7835,8 +7835,8 @@
         </p:nvSpPr>
         <p:spPr>
           <a:xfrm>
-            <a:off x="4803648" y="4748022"/>
-            <a:ext cx="1101344" cy="329184"/>
+            <a:off x="5120640" y="4748022"/>
+            <a:ext cx="1629664" cy="329184"/>
           </a:xfrm>
           <a:prstGeom prst="rect">
             <a:avLst/>
@@ -7857,7 +7857,7 @@
                   <a:schemeClr val="tx1"/>
                 </a:solidFill>
               </a:rPr>
-              <a:t>zaterdag</a:t>
+              <a:t>«Tot morgen!»</a:t>
             </a:r>
             <a:endParaRPr lang="en-US" sz="1600" dirty="0"/>
           </a:p>
@@ -7893,7 +7893,7 @@
                   <a:schemeClr val="accent5"/>
                 </a:solidFill>
               </a:rPr>
-              <a:t>Demain, c’est samedi.</a:t>
+              <a:t>Après le cours, je dis « à demain ».</a:t>
             </a:r>
             <a:endParaRPr lang="en-US" sz="1400" dirty="0"/>
           </a:p>
@@ -11636,7 +11636,7 @@
                   <a:schemeClr val="tx1"/>
                 </a:solidFill>
               </a:rPr>
-              <a:t>In de morgen is het rustig.</a:t>
+              <a:t>In de middag is het rustig.</a:t>
             </a:r>
             <a:endParaRPr lang="en-US" sz="2000" dirty="0"/>
           </a:p>
@@ -11764,6 +11764,14 @@
               <a:t>Piège pour francophones — </a:t>
             </a:r>
             <a:r>
+              <a:rPr lang="en-US" sz="1700" dirty="0">
+                <a:solidFill>
+                  <a:schemeClr val="tx1"/>
+                </a:solidFill>
+              </a:rPr>
+              <a:t>Le français dit « </a:t>
+            </a:r>
+            <a:r>
               <a:rPr lang="en-US" sz="1700" i="1" dirty="0">
                 <a:solidFill>
                   <a:schemeClr val="tx1"/>
@@ -11777,7 +11785,7 @@
                   <a:schemeClr val="tx1"/>
                 </a:solidFill>
               </a:rPr>
-              <a:t> a trois traductions : </a:t>
+              <a:t> » ; le néerlandais choisit : </a:t>
             </a:r>
             <a:r>
               <a:rPr lang="en-US" sz="1700" i="1" dirty="0">
@@ -11785,47 +11793,55 @@
                   <a:schemeClr val="tx1"/>
                 </a:solidFill>
               </a:rPr>
+              <a:t>’s middags</a:t>
+            </a:r>
+            <a:r>
+              <a:rPr lang="en-US" sz="1700" dirty="0">
+                <a:solidFill>
+                  <a:schemeClr val="tx1"/>
+                </a:solidFill>
+              </a:rPr>
+              <a:t> (d’habitude), </a:t>
+            </a:r>
+            <a:r>
+              <a:rPr lang="en-US" sz="1700" i="1" dirty="0">
+                <a:solidFill>
+                  <a:schemeClr val="tx1"/>
+                </a:solidFill>
+              </a:rPr>
+              <a:t>vanmiddag</a:t>
+            </a:r>
+            <a:r>
+              <a:rPr lang="en-US" sz="1700" dirty="0">
+                <a:solidFill>
+                  <a:schemeClr val="tx1"/>
+                </a:solidFill>
+              </a:rPr>
+              <a:t> (aujourd’hui), </a:t>
+            </a:r>
+            <a:r>
+              <a:rPr lang="en-US" sz="1700" i="1" dirty="0">
+                <a:solidFill>
+                  <a:schemeClr val="tx1"/>
+                </a:solidFill>
+              </a:rPr>
+              <a:t>in de middag</a:t>
+            </a:r>
+            <a:r>
+              <a:rPr lang="en-US" sz="1700" dirty="0">
+                <a:solidFill>
+                  <a:schemeClr val="tx1"/>
+                </a:solidFill>
+              </a:rPr>
+              <a:t> (en général). Pour saluer : </a:t>
+            </a:r>
+            <a:r>
+              <a:rPr lang="en-US" sz="1700" i="1" dirty="0">
+                <a:solidFill>
+                  <a:schemeClr val="tx1"/>
+                </a:solidFill>
+              </a:rPr>
               <a:t>Goedemiddag!</a:t>
-            </a:r>
-            <a:r>
-              <a:rPr lang="en-US" sz="1700" dirty="0">
-                <a:solidFill>
-                  <a:schemeClr val="tx1"/>
-                </a:solidFill>
-              </a:rPr>
-              <a:t> (je salue), </a:t>
-            </a:r>
-            <a:r>
-              <a:rPr lang="en-US" sz="1700" i="1" dirty="0">
-                <a:solidFill>
-                  <a:schemeClr val="tx1"/>
-                </a:solidFill>
-              </a:rPr>
-              <a:t>’s middags</a:t>
-            </a:r>
-            <a:r>
-              <a:rPr lang="en-US" sz="1700" dirty="0">
-                <a:solidFill>
-                  <a:schemeClr val="tx1"/>
-                </a:solidFill>
-              </a:rPr>
-              <a:t> (d’habitude), </a:t>
-            </a:r>
-            <a:r>
-              <a:rPr lang="en-US" sz="1700" i="1" dirty="0">
-                <a:solidFill>
-                  <a:schemeClr val="tx1"/>
-                </a:solidFill>
-              </a:rPr>
-              <a:t>vanmiddag</a:t>
-            </a:r>
-            <a:r>
-              <a:rPr lang="en-US" sz="1700" dirty="0">
-                <a:solidFill>
-                  <a:schemeClr val="tx1"/>
-                </a:solidFill>
-              </a:rPr>
-              <a:t> (cet après-midi). Le français dit la même chose dans les trois cas !</a:t>
             </a:r>
             <a:endParaRPr lang="en-US" sz="1700" dirty="0"/>
           </a:p>
@@ -13552,7 +13568,7 @@
                             <a:schemeClr val="tx1"/>
                           </a:solidFill>
                         </a:rPr>
-                        <a:t>Morgens werk ik op school.</a:t>
+                        <a:t>’s Morgens werk ik op school.</a:t>
                       </a:r>
                       <a:endParaRPr lang="en-US" sz="2000" dirty="0"/>
                     </a:p>
@@ -15454,7 +15470,7 @@
                   <a:schemeClr val="accent5"/>
                 </a:solidFill>
               </a:rPr>
-              <a:t>Le professeur lit le texte 2, puis le texte 3. Retrouvez chaque case en néerlandais. Grille complète : « </a:t>
+              <a:t>Couche 1 · seul · 5 min. Le professeur lit les textes 2 et 3 : cochez chaque case entendue. Grille complète : « </a:t>
             </a:r>
             <a:r>
               <a:rPr lang="en-US" sz="1600" b="1" i="1" dirty="0">
@@ -15462,7 +15478,7 @@
                   <a:schemeClr val="accent5"/>
                 </a:solidFill>
               </a:rPr>
-              <a:t>Bingo!</a:t>
+              <a:t>Bingo !</a:t>
             </a:r>
             <a:r>
               <a:rPr lang="en-US" sz="1600" i="1" dirty="0">
@@ -15503,7 +15519,7 @@
                 <a:gridCol w="3694176"/>
                 <a:gridCol w="3703320"/>
               </a:tblGrid>
-              <a:tr h="1457554">
+              <a:tr h="1192378">
                 <a:tc>
                   <a:txBody>
                     <a:bodyPr/>
@@ -15513,7 +15529,7 @@
                         <a:buNone/>
                       </a:pPr>
                       <a:r>
-                        <a:rPr lang="en-US" sz="1900" dirty="0">
+                        <a:rPr lang="en-US" sz="1700" dirty="0">
                           <a:solidFill>
                             <a:schemeClr val="tx1"/>
                           </a:solidFill>
@@ -15522,14 +15538,14 @@
 </a:t>
                       </a:r>
                       <a:r>
-                        <a:rPr lang="en-US" sz="1900" dirty="0">
+                        <a:rPr lang="en-US" sz="1700" dirty="0">
                           <a:solidFill>
                             <a:schemeClr val="accent5"/>
                           </a:solidFill>
                         </a:rPr>
                         <a:t>……………………………………</a:t>
                       </a:r>
-                      <a:endParaRPr lang="en-US" sz="1900" dirty="0"/>
+                      <a:endParaRPr lang="en-US" sz="1700" dirty="0"/>
                     </a:p>
                   </a:txBody>
                   <a:tcPr marL="91440" marR="91440" marT="54864" marB="54864" anchor="ctr">
@@ -15583,7 +15599,7 @@
                         <a:buNone/>
                       </a:pPr>
                       <a:r>
-                        <a:rPr lang="en-US" sz="1900" dirty="0">
+                        <a:rPr lang="en-US" sz="1700" dirty="0">
                           <a:solidFill>
                             <a:schemeClr val="tx1"/>
                           </a:solidFill>
@@ -15592,14 +15608,14 @@
 </a:t>
                       </a:r>
                       <a:r>
-                        <a:rPr lang="en-US" sz="1900" dirty="0">
+                        <a:rPr lang="en-US" sz="1700" dirty="0">
                           <a:solidFill>
                             <a:schemeClr val="accent5"/>
                           </a:solidFill>
                         </a:rPr>
                         <a:t>……………………………………</a:t>
                       </a:r>
-                      <a:endParaRPr lang="en-US" sz="1900" dirty="0"/>
+                      <a:endParaRPr lang="en-US" sz="1700" dirty="0"/>
                     </a:p>
                   </a:txBody>
                   <a:tcPr marL="91440" marR="91440" marT="54864" marB="54864" anchor="ctr">
@@ -15653,7 +15669,7 @@
                         <a:buNone/>
                       </a:pPr>
                       <a:r>
-                        <a:rPr lang="en-US" sz="1900" dirty="0">
+                        <a:rPr lang="en-US" sz="1700" dirty="0">
                           <a:solidFill>
                             <a:schemeClr val="tx1"/>
                           </a:solidFill>
@@ -15662,14 +15678,14 @@
 </a:t>
                       </a:r>
                       <a:r>
-                        <a:rPr lang="en-US" sz="1900" dirty="0">
+                        <a:rPr lang="en-US" sz="1700" dirty="0">
                           <a:solidFill>
                             <a:schemeClr val="accent5"/>
                           </a:solidFill>
                         </a:rPr>
                         <a:t>……………………………………</a:t>
                       </a:r>
-                      <a:endParaRPr lang="en-US" sz="1900" dirty="0"/>
+                      <a:endParaRPr lang="en-US" sz="1700" dirty="0"/>
                     </a:p>
                   </a:txBody>
                   <a:tcPr marL="91440" marR="91440" marT="54864" marB="54864" anchor="ctr">
@@ -15715,7 +15731,7 @@
                   </a:tcPr>
                 </a:tc>
               </a:tr>
-              <a:tr h="1457554">
+              <a:tr h="1455725">
                 <a:tc>
                   <a:txBody>
                     <a:bodyPr/>
@@ -15725,7 +15741,7 @@
                         <a:buNone/>
                       </a:pPr>
                       <a:r>
-                        <a:rPr lang="en-US" sz="1900" dirty="0">
+                        <a:rPr lang="en-US" sz="1700" dirty="0">
                           <a:solidFill>
                             <a:schemeClr val="tx1"/>
                           </a:solidFill>
@@ -15734,14 +15750,14 @@
 </a:t>
                       </a:r>
                       <a:r>
-                        <a:rPr lang="en-US" sz="1900" dirty="0">
+                        <a:rPr lang="en-US" sz="1700" dirty="0">
                           <a:solidFill>
                             <a:schemeClr val="accent5"/>
                           </a:solidFill>
                         </a:rPr>
                         <a:t>……………………………………</a:t>
                       </a:r>
-                      <a:endParaRPr lang="en-US" sz="1900" dirty="0"/>
+                      <a:endParaRPr lang="en-US" sz="1700" dirty="0"/>
                     </a:p>
                   </a:txBody>
                   <a:tcPr marL="91440" marR="91440" marT="54864" marB="54864" anchor="ctr">
@@ -15795,7 +15811,7 @@
                         <a:buNone/>
                       </a:pPr>
                       <a:r>
-                        <a:rPr lang="en-US" sz="1900" dirty="0">
+                        <a:rPr lang="en-US" sz="1700" dirty="0">
                           <a:solidFill>
                             <a:schemeClr val="tx1"/>
                           </a:solidFill>
@@ -15804,14 +15820,14 @@
 </a:t>
                       </a:r>
                       <a:r>
-                        <a:rPr lang="en-US" sz="1900" dirty="0">
+                        <a:rPr lang="en-US" sz="1700" dirty="0">
                           <a:solidFill>
                             <a:schemeClr val="accent5"/>
                           </a:solidFill>
                         </a:rPr>
                         <a:t>……………………………………</a:t>
                       </a:r>
-                      <a:endParaRPr lang="en-US" sz="1900" dirty="0"/>
+                      <a:endParaRPr lang="en-US" sz="1700" dirty="0"/>
                     </a:p>
                   </a:txBody>
                   <a:tcPr marL="91440" marR="91440" marT="54864" marB="54864" anchor="ctr">
@@ -15865,7 +15881,7 @@
                         <a:buNone/>
                       </a:pPr>
                       <a:r>
-                        <a:rPr lang="en-US" sz="1900" dirty="0">
+                        <a:rPr lang="en-US" sz="1700" dirty="0">
                           <a:solidFill>
                             <a:schemeClr val="tx1"/>
                           </a:solidFill>
@@ -15874,14 +15890,14 @@
 </a:t>
                       </a:r>
                       <a:r>
-                        <a:rPr lang="en-US" sz="1900" dirty="0">
+                        <a:rPr lang="en-US" sz="1700" dirty="0">
                           <a:solidFill>
                             <a:schemeClr val="accent5"/>
                           </a:solidFill>
                         </a:rPr>
                         <a:t>……………………………………</a:t>
                       </a:r>
-                      <a:endParaRPr lang="en-US" sz="1900" dirty="0"/>
+                      <a:endParaRPr lang="en-US" sz="1700" dirty="0"/>
                     </a:p>
                   </a:txBody>
                   <a:tcPr marL="91440" marR="91440" marT="54864" marB="54864" anchor="ctr">
@@ -15927,7 +15943,7 @@
                   </a:tcPr>
                 </a:tc>
               </a:tr>
-              <a:tr h="1457554">
+              <a:tr h="1455725">
                 <a:tc>
                   <a:txBody>
                     <a:bodyPr/>
@@ -15937,7 +15953,7 @@
                         <a:buNone/>
                       </a:pPr>
                       <a:r>
-                        <a:rPr lang="en-US" sz="1900" dirty="0">
+                        <a:rPr lang="en-US" sz="1700" dirty="0">
                           <a:solidFill>
                             <a:schemeClr val="tx1"/>
                           </a:solidFill>
@@ -15946,14 +15962,14 @@
 </a:t>
                       </a:r>
                       <a:r>
-                        <a:rPr lang="en-US" sz="1900" dirty="0">
+                        <a:rPr lang="en-US" sz="1700" dirty="0">
                           <a:solidFill>
                             <a:schemeClr val="accent5"/>
                           </a:solidFill>
                         </a:rPr>
                         <a:t>…………………………</a:t>
                       </a:r>
-                      <a:endParaRPr lang="en-US" sz="1900" dirty="0"/>
+                      <a:endParaRPr lang="en-US" sz="1700" dirty="0"/>
                     </a:p>
                   </a:txBody>
                   <a:tcPr marL="91440" marR="91440" marT="54864" marB="54864" anchor="ctr">
@@ -16007,7 +16023,7 @@
                         <a:buNone/>
                       </a:pPr>
                       <a:r>
-                        <a:rPr lang="en-US" sz="1900" dirty="0">
+                        <a:rPr lang="en-US" sz="1700" dirty="0">
                           <a:solidFill>
                             <a:schemeClr val="tx1"/>
                           </a:solidFill>
@@ -16016,14 +16032,14 @@
 </a:t>
                       </a:r>
                       <a:r>
-                        <a:rPr lang="en-US" sz="1900" dirty="0">
+                        <a:rPr lang="en-US" sz="1700" dirty="0">
                           <a:solidFill>
                             <a:schemeClr val="accent5"/>
                           </a:solidFill>
                         </a:rPr>
                         <a:t>……………………………………</a:t>
                       </a:r>
-                      <a:endParaRPr lang="en-US" sz="1900" dirty="0"/>
+                      <a:endParaRPr lang="en-US" sz="1700" dirty="0"/>
                     </a:p>
                   </a:txBody>
                   <a:tcPr marL="91440" marR="91440" marT="54864" marB="54864" anchor="ctr">
@@ -16077,7 +16093,7 @@
                         <a:buNone/>
                       </a:pPr>
                       <a:r>
-                        <a:rPr lang="en-US" sz="1900" dirty="0">
+                        <a:rPr lang="en-US" sz="1700" dirty="0">
                           <a:solidFill>
                             <a:schemeClr val="tx1"/>
                           </a:solidFill>
@@ -16086,14 +16102,14 @@
 </a:t>
                       </a:r>
                       <a:r>
-                        <a:rPr lang="en-US" sz="1900" dirty="0">
+                        <a:rPr lang="en-US" sz="1700" dirty="0">
                           <a:solidFill>
                             <a:schemeClr val="accent5"/>
                           </a:solidFill>
                         </a:rPr>
                         <a:t>……………………………………</a:t>
                       </a:r>
-                      <a:endParaRPr lang="en-US" sz="1900" dirty="0"/>
+                      <a:endParaRPr lang="en-US" sz="1700" dirty="0"/>
                     </a:p>
                   </a:txBody>
                   <a:tcPr marL="91440" marR="91440" marT="54864" marB="54864" anchor="ctr">
@@ -16397,7 +16413,7 @@
                   <a:schemeClr val="accent5"/>
                 </a:solidFill>
               </a:rPr>
-              <a:t>Le professeur lit le texte 2, puis le texte 3. Retrouvez chaque case en néerlandais. Grille complète : « </a:t>
+              <a:t>Couche 1 · seul · 5 min. Le professeur lit les textes 2 et 3 : cochez chaque case entendue. Grille complète : « </a:t>
             </a:r>
             <a:r>
               <a:rPr lang="en-US" sz="1600" b="1" i="1" dirty="0">
@@ -16405,7 +16421,7 @@
                   <a:schemeClr val="accent5"/>
                 </a:solidFill>
               </a:rPr>
-              <a:t>Bingo!</a:t>
+              <a:t>Bingo !</a:t>
             </a:r>
             <a:r>
               <a:rPr lang="en-US" sz="1600" i="1" dirty="0">
@@ -16446,7 +16462,7 @@
                 <a:gridCol w="3694176"/>
                 <a:gridCol w="3703320"/>
               </a:tblGrid>
-              <a:tr h="1457554">
+              <a:tr h="1192378">
                 <a:tc>
                   <a:txBody>
                     <a:bodyPr/>
@@ -16456,7 +16472,7 @@
                         <a:buNone/>
                       </a:pPr>
                       <a:r>
-                        <a:rPr lang="en-US" sz="1900" dirty="0">
+                        <a:rPr lang="en-US" sz="1700" dirty="0">
                           <a:solidFill>
                             <a:schemeClr val="tx1"/>
                           </a:solidFill>
@@ -16465,14 +16481,14 @@
 </a:t>
                       </a:r>
                       <a:r>
-                        <a:rPr lang="en-US" sz="1900" b="1" dirty="0">
+                        <a:rPr lang="en-US" sz="1700" b="1" dirty="0">
                           <a:solidFill>
                             <a:schemeClr val="accent3"/>
                           </a:solidFill>
                         </a:rPr>
                         <a:t>’s Morgens werk ik op school.</a:t>
                       </a:r>
-                      <a:endParaRPr lang="en-US" sz="1900" dirty="0"/>
+                      <a:endParaRPr lang="en-US" sz="1700" dirty="0"/>
                     </a:p>
                   </a:txBody>
                   <a:tcPr marL="91440" marR="91440" marT="54864" marB="54864" anchor="ctr">
@@ -16526,7 +16542,7 @@
                         <a:buNone/>
                       </a:pPr>
                       <a:r>
-                        <a:rPr lang="en-US" sz="1900" dirty="0">
+                        <a:rPr lang="en-US" sz="1700" dirty="0">
                           <a:solidFill>
                             <a:schemeClr val="tx1"/>
                           </a:solidFill>
@@ -16535,14 +16551,14 @@
 </a:t>
                       </a:r>
                       <a:r>
-                        <a:rPr lang="en-US" sz="1900" b="1" dirty="0">
+                        <a:rPr lang="en-US" sz="1700" b="1" dirty="0">
                           <a:solidFill>
                             <a:schemeClr val="accent3"/>
                           </a:solidFill>
                         </a:rPr>
                         <a:t>Vanmiddag ga ik naar de dokter.</a:t>
                       </a:r>
-                      <a:endParaRPr lang="en-US" sz="1900" dirty="0"/>
+                      <a:endParaRPr lang="en-US" sz="1700" dirty="0"/>
                     </a:p>
                   </a:txBody>
                   <a:tcPr marL="91440" marR="91440" marT="54864" marB="54864" anchor="ctr">
@@ -16596,7 +16612,7 @@
                         <a:buNone/>
                       </a:pPr>
                       <a:r>
-                        <a:rPr lang="en-US" sz="1900" dirty="0">
+                        <a:rPr lang="en-US" sz="1700" dirty="0">
                           <a:solidFill>
                             <a:schemeClr val="tx1"/>
                           </a:solidFill>
@@ -16605,14 +16621,14 @@
 </a:t>
                       </a:r>
                       <a:r>
-                        <a:rPr lang="en-US" sz="1900" b="1" dirty="0">
+                        <a:rPr lang="en-US" sz="1700" b="1" dirty="0">
                           <a:solidFill>
                             <a:schemeClr val="accent3"/>
                           </a:solidFill>
                         </a:rPr>
                         <a:t>Vanavond kijk ik een film met Emma.</a:t>
                       </a:r>
-                      <a:endParaRPr lang="en-US" sz="1900" dirty="0"/>
+                      <a:endParaRPr lang="en-US" sz="1700" dirty="0"/>
                     </a:p>
                   </a:txBody>
                   <a:tcPr marL="91440" marR="91440" marT="54864" marB="54864" anchor="ctr">
@@ -16658,7 +16674,7 @@
                   </a:tcPr>
                 </a:tc>
               </a:tr>
-              <a:tr h="1457554">
+              <a:tr h="1455725">
                 <a:tc>
                   <a:txBody>
                     <a:bodyPr/>
@@ -16668,7 +16684,7 @@
                         <a:buNone/>
                       </a:pPr>
                       <a:r>
-                        <a:rPr lang="en-US" sz="1900" dirty="0">
+                        <a:rPr lang="en-US" sz="1700" dirty="0">
                           <a:solidFill>
                             <a:schemeClr val="tx1"/>
                           </a:solidFill>
@@ -16677,14 +16693,14 @@
 </a:t>
                       </a:r>
                       <a:r>
-                        <a:rPr lang="en-US" sz="1900" b="1" dirty="0">
+                        <a:rPr lang="en-US" sz="1700" b="1" dirty="0">
                           <a:solidFill>
                             <a:schemeClr val="accent3"/>
                           </a:solidFill>
                         </a:rPr>
                         <a:t>Vandaag heb ik een vergadering op het werk.</a:t>
                       </a:r>
-                      <a:endParaRPr lang="en-US" sz="1900" dirty="0"/>
+                      <a:endParaRPr lang="en-US" sz="1700" dirty="0"/>
                     </a:p>
                   </a:txBody>
                   <a:tcPr marL="91440" marR="91440" marT="54864" marB="54864" anchor="ctr">
@@ -16738,7 +16754,7 @@
                         <a:buNone/>
                       </a:pPr>
                       <a:r>
-                        <a:rPr lang="en-US" sz="1900" dirty="0">
+                        <a:rPr lang="en-US" sz="1700" dirty="0">
                           <a:solidFill>
                             <a:schemeClr val="tx1"/>
                           </a:solidFill>
@@ -16747,14 +16763,14 @@
 </a:t>
                       </a:r>
                       <a:r>
-                        <a:rPr lang="en-US" sz="1900" b="1" dirty="0">
+                        <a:rPr lang="en-US" sz="1700" b="1" dirty="0">
                           <a:solidFill>
                             <a:schemeClr val="accent3"/>
                           </a:solidFill>
                         </a:rPr>
                         <a:t>Goedenacht! · Welterusten!</a:t>
                       </a:r>
-                      <a:endParaRPr lang="en-US" sz="1900" dirty="0"/>
+                      <a:endParaRPr lang="en-US" sz="1700" dirty="0"/>
                     </a:p>
                   </a:txBody>
                   <a:tcPr marL="91440" marR="91440" marT="54864" marB="54864" anchor="ctr">
@@ -16808,7 +16824,7 @@
                         <a:buNone/>
                       </a:pPr>
                       <a:r>
-                        <a:rPr lang="en-US" sz="1900" dirty="0">
+                        <a:rPr lang="en-US" sz="1700" dirty="0">
                           <a:solidFill>
                             <a:schemeClr val="tx1"/>
                           </a:solidFill>
@@ -16817,14 +16833,14 @@
 </a:t>
                       </a:r>
                       <a:r>
-                        <a:rPr lang="en-US" sz="1900" b="1" dirty="0">
+                        <a:rPr lang="en-US" sz="1700" b="1" dirty="0">
                           <a:solidFill>
                             <a:schemeClr val="accent3"/>
                           </a:solidFill>
                         </a:rPr>
                         <a:t>’s Avonds ga ik naar huis.</a:t>
                       </a:r>
-                      <a:endParaRPr lang="en-US" sz="1900" dirty="0"/>
+                      <a:endParaRPr lang="en-US" sz="1700" dirty="0"/>
                     </a:p>
                   </a:txBody>
                   <a:tcPr marL="91440" marR="91440" marT="54864" marB="54864" anchor="ctr">
@@ -16870,7 +16886,7 @@
                   </a:tcPr>
                 </a:tc>
               </a:tr>
-              <a:tr h="1457554">
+              <a:tr h="1455725">
                 <a:tc>
                   <a:txBody>
                     <a:bodyPr/>
@@ -16880,7 +16896,7 @@
                         <a:buNone/>
                       </a:pPr>
                       <a:r>
-                        <a:rPr lang="en-US" sz="1900" dirty="0">
+                        <a:rPr lang="en-US" sz="1700" dirty="0">
                           <a:solidFill>
                             <a:schemeClr val="tx1"/>
                           </a:solidFill>
@@ -16889,14 +16905,14 @@
 </a:t>
                       </a:r>
                       <a:r>
-                        <a:rPr lang="en-US" sz="1900" b="1" dirty="0">
+                        <a:rPr lang="en-US" sz="1700" b="1" dirty="0">
                           <a:solidFill>
                             <a:schemeClr val="accent3"/>
                           </a:solidFill>
                         </a:rPr>
                         <a:t>Vandaag ben ik moe.</a:t>
                       </a:r>
-                      <a:endParaRPr lang="en-US" sz="1900" dirty="0"/>
+                      <a:endParaRPr lang="en-US" sz="1700" dirty="0"/>
                     </a:p>
                   </a:txBody>
                   <a:tcPr marL="91440" marR="91440" marT="54864" marB="54864" anchor="ctr">
@@ -16950,7 +16966,7 @@
                         <a:buNone/>
                       </a:pPr>
                       <a:r>
-                        <a:rPr lang="en-US" sz="1900" dirty="0">
+                        <a:rPr lang="en-US" sz="1700" dirty="0">
                           <a:solidFill>
                             <a:schemeClr val="tx1"/>
                           </a:solidFill>
@@ -16959,14 +16975,14 @@
 </a:t>
                       </a:r>
                       <a:r>
-                        <a:rPr lang="en-US" sz="1900" b="1" dirty="0">
+                        <a:rPr lang="en-US" sz="1700" b="1" dirty="0">
                           <a:solidFill>
                             <a:schemeClr val="accent3"/>
                           </a:solidFill>
                         </a:rPr>
-                        <a:t>’s Morgens zeg ik «goedemorgen» tegen de kinderen.</a:t>
+                        <a:t>’s Morgens zeg ik «Goedemorgen!» tegen de kinderen.</a:t>
                       </a:r>
-                      <a:endParaRPr lang="en-US" sz="1900" dirty="0"/>
+                      <a:endParaRPr lang="en-US" sz="1700" dirty="0"/>
                     </a:p>
                   </a:txBody>
                   <a:tcPr marL="91440" marR="91440" marT="54864" marB="54864" anchor="ctr">
@@ -17020,7 +17036,7 @@
                         <a:buNone/>
                       </a:pPr>
                       <a:r>
-                        <a:rPr lang="en-US" sz="1900" dirty="0">
+                        <a:rPr lang="en-US" sz="1700" dirty="0">
                           <a:solidFill>
                             <a:schemeClr val="tx1"/>
                           </a:solidFill>
@@ -17029,14 +17045,14 @@
 </a:t>
                       </a:r>
                       <a:r>
-                        <a:rPr lang="en-US" sz="1900" b="1" dirty="0">
+                        <a:rPr lang="en-US" sz="1700" b="1" dirty="0">
                           <a:solidFill>
                             <a:schemeClr val="accent3"/>
                           </a:solidFill>
                         </a:rPr>
                         <a:t>’s Middags is het rustig op het werk.</a:t>
                       </a:r>
-                      <a:endParaRPr lang="en-US" sz="1900" dirty="0"/>
+                      <a:endParaRPr lang="en-US" sz="1700" dirty="0"/>
                     </a:p>
                   </a:txBody>
                   <a:tcPr marL="91440" marR="91440" marT="54864" marB="54864" anchor="ctr">
@@ -19129,7 +19145,7 @@
                   <a:schemeClr val="tx1"/>
                 </a:solidFill>
               </a:rPr>
-              <a:t> · Vanmorgen zeg ik «Goedemorgen!» tegen mijn collega’s.</a:t>
+              <a:t> · Vanmorgen zeg ik «Goedemorgen allemaal!»</a:t>
             </a:r>
             <a:endParaRPr lang="en-US" sz="2300" dirty="0"/>
           </a:p>
@@ -19179,7 +19195,7 @@
                   <a:schemeClr val="tx1"/>
                 </a:solidFill>
               </a:rPr>
-              <a:t> · Om zeven uur sta ik op. · Om één uur lunch ik.</a:t>
+              <a:t> · Om zeven uur sta ik elke dag op. · Om één uur lunch ik meestal.</a:t>
             </a:r>
             <a:endParaRPr lang="en-US" sz="2300" dirty="0"/>
           </a:p>
@@ -19204,7 +19220,7 @@
                   <a:schemeClr val="tx1"/>
                 </a:solidFill>
               </a:rPr>
-              <a:t> · Na de les zeg ik «Tot morgen!».</a:t>
+              <a:t> · Na de les zeg ik «Tot morgen!»</a:t>
             </a:r>
             <a:endParaRPr lang="en-US" sz="2300" dirty="0"/>
           </a:p>
@@ -19241,7 +19257,7 @@
                   <a:schemeClr val="tx1"/>
                 </a:solidFill>
               </a:rPr>
-              <a:t>Werk jij ook ’s avonds?</a:t>
+              <a:t>Werk jij ook ’s avonds thuis?</a:t>
             </a:r>
             <a:r>
               <a:rPr lang="en-US" sz="2300" dirty="0">
@@ -19257,7 +19273,23 @@
                   <a:schemeClr val="tx1"/>
                 </a:solidFill>
               </a:rPr>
-              <a:t>Ja! / Nee.</a:t>
+              <a:t>Ja, ik ook.</a:t>
+            </a:r>
+            <a:r>
+              <a:rPr lang="en-US" sz="2300" dirty="0">
+                <a:solidFill>
+                  <a:schemeClr val="tx1"/>
+                </a:solidFill>
+              </a:rPr>
+              <a:t> / </a:t>
+            </a:r>
+            <a:r>
+              <a:rPr lang="en-US" sz="2300" i="1" dirty="0">
+                <a:solidFill>
+                  <a:schemeClr val="tx1"/>
+                </a:solidFill>
+              </a:rPr>
+              <a:t>Nee, ik niet.</a:t>
             </a:r>
             <a:r>
               <a:rPr lang="en-US" sz="2300" dirty="0">
@@ -19404,7 +19436,7 @@
                   <a:schemeClr val="tx1"/>
                 </a:solidFill>
               </a:rPr>
-              <a:t>, au moins 1 par famille (A, B, C, D) + 1 libre.</a:t>
+              <a:t> : 2 A · 3 B · 2 C · 2 D · 1 libre (grille du livret).</a:t>
             </a:r>
             <a:endParaRPr lang="en-US" sz="1800" dirty="0"/>
           </a:p>
@@ -19710,7 +19742,7 @@
                   <a:schemeClr val="tx1"/>
                 </a:solidFill>
               </a:rPr>
-              <a:t>Groupe de 4 ou 5 · 15 min. Cartes-moments : </a:t>
+              <a:t>Couche 2 · groupe de 4 ou 5 · 15 min. Cartes-moments : </a:t>
             </a:r>
             <a:r>
               <a:rPr lang="en-US" sz="1800" b="1" dirty="0">
@@ -21799,7 +21831,7 @@
                   <a:schemeClr val="accent5"/>
                 </a:solidFill>
               </a:rPr>
-              <a:t>Réponse complète : </a:t>
+              <a:t>À l’oral, répondez par une phrase complète : </a:t>
             </a:r>
             <a:r>
               <a:rPr lang="en-US" sz="1500" i="1" dirty="0">
@@ -21807,7 +21839,7 @@
                   <a:schemeClr val="accent5"/>
                 </a:solidFill>
               </a:rPr>
-              <a:t>’s Morgens zeg ik «Goedemorgen!».</a:t>
+              <a:t>’s Middags zeg ik …</a:t>
             </a:r>
             <a:r>
               <a:rPr lang="en-US" sz="1500" i="1" dirty="0">
@@ -23216,7 +23248,7 @@
                   <a:schemeClr val="accent5"/>
                 </a:solidFill>
               </a:rPr>
-              <a:t>Réponse complète : </a:t>
+              <a:t>À l’oral, répondez par une phrase complète : </a:t>
             </a:r>
             <a:r>
               <a:rPr lang="en-US" sz="1500" i="1" dirty="0">
@@ -23224,7 +23256,7 @@
                   <a:schemeClr val="accent5"/>
                 </a:solidFill>
               </a:rPr>
-              <a:t>’s Morgens zeg ik «Goedemorgen!».</a:t>
+              <a:t>’s Middags zeg ik …</a:t>
             </a:r>
             <a:r>
               <a:rPr lang="en-US" sz="1500" i="1" dirty="0">
@@ -23452,7 +23484,7 @@
                   <a:schemeClr val="accent5"/>
                 </a:solidFill>
               </a:rPr>
-              <a:t>Saluez la personne avec la bonne formule et son nom.</a:t>
+              <a:t>Saluez avec la bonne formule, suivie du nom quand il est donné.</a:t>
             </a:r>
             <a:endParaRPr lang="en-US" sz="1600" dirty="0"/>
           </a:p>
@@ -23532,7 +23564,7 @@
                   <a:schemeClr val="tx1"/>
                 </a:solidFill>
               </a:rPr>
-              <a:t>13.30 · Meneer Janssens → </a:t>
+              <a:t>12.00 · Meneer Janssens → </a:t>
             </a:r>
             <a:r>
               <a:rPr lang="en-US" sz="2400" dirty="0">
@@ -23653,7 +23685,7 @@
                   <a:schemeClr val="tx1"/>
                 </a:solidFill>
               </a:rPr>
-              <a:t>10.00 · un ami, en passant → </a:t>
+              <a:t>10.00 · Emma, une amie, en passant → </a:t>
             </a:r>
             <a:r>
               <a:rPr lang="en-US" sz="2400" dirty="0">
@@ -23661,7 +23693,7 @@
                   <a:schemeClr val="accent5"/>
                 </a:solidFill>
               </a:rPr>
-              <a:t>………………</a:t>
+              <a:t>………………………………</a:t>
             </a:r>
             <a:endParaRPr lang="en-US" sz="2400" dirty="0"/>
           </a:p>
@@ -23954,7 +23986,7 @@
                   <a:schemeClr val="accent5"/>
                 </a:solidFill>
               </a:rPr>
-              <a:t>Saluez la personne avec la bonne formule et son nom.</a:t>
+              <a:t>Saluez avec la bonne formule, suivie du nom quand il est donné.</a:t>
             </a:r>
             <a:endParaRPr lang="en-US" sz="1600" dirty="0"/>
           </a:p>
@@ -24034,7 +24066,7 @@
                   <a:schemeClr val="tx1"/>
                 </a:solidFill>
               </a:rPr>
-              <a:t>13.30 · Meneer Janssens → </a:t>
+              <a:t>12.00 · Meneer Janssens → </a:t>
             </a:r>
             <a:r>
               <a:rPr lang="en-US" sz="2400" b="1" dirty="0">
@@ -24155,7 +24187,7 @@
                   <a:schemeClr val="tx1"/>
                 </a:solidFill>
               </a:rPr>
-              <a:t>10.00 · un ami, en passant → </a:t>
+              <a:t>10.00 · Emma, une amie, en passant → </a:t>
             </a:r>
             <a:r>
               <a:rPr lang="en-US" sz="2400" b="1" dirty="0">
@@ -24163,7 +24195,7 @@
                   <a:schemeClr val="accent3"/>
                 </a:solidFill>
               </a:rPr>
-              <a:t>Hoi! / Dag!</a:t>
+              <a:t>Hoi Emma! / Dag Emma!</a:t>
             </a:r>
             <a:endParaRPr lang="en-US" sz="2400" dirty="0"/>
           </a:p>
@@ -24404,6 +24436,32 @@
                 </a:solidFill>
               </a:rPr>
               <a:t> : seulement entre amis.</a:t>
+            </a:r>
+            <a:endParaRPr lang="en-US" sz="1800" dirty="0"/>
+          </a:p>
+          <a:p>
+            <a:pPr marL="177800" indent="-177800">
+              <a:spcAft>
+                <a:spcPts val="600"/>
+              </a:spcAft>
+              <a:buSzPct val="100000"/>
+              <a:buChar char="•"/>
+            </a:pPr>
+            <a:r>
+              <a:rPr lang="en-US" sz="1800" i="1" dirty="0">
+                <a:solidFill>
+                  <a:schemeClr val="tx1"/>
+                </a:solidFill>
+              </a:rPr>
+              <a:t>meneer</a:t>
+            </a:r>
+            <a:r>
+              <a:rPr lang="en-US" sz="1800" dirty="0">
+                <a:solidFill>
+                  <a:schemeClr val="tx1"/>
+                </a:solidFill>
+              </a:rPr>
+              <a:t> : minuscule au milieu de la phrase.</a:t>
             </a:r>
             <a:endParaRPr lang="en-US" sz="1800" dirty="0"/>
           </a:p>
@@ -24944,7 +25002,7 @@
                   <a:schemeClr val="tx1"/>
                 </a:solidFill>
               </a:rPr>
-              <a:t>Écrire </a:t>
+              <a:t>Terminer </a:t>
             </a:r>
             <a:r>
               <a:rPr lang="en-US" sz="1700" b="1" dirty="0">
@@ -24952,7 +25010,7 @@
                   <a:schemeClr val="tx1"/>
                 </a:solidFill>
               </a:rPr>
-              <a:t>5 phrases</a:t>
+              <a:t>1.1.3 Mijn dag</a:t>
             </a:r>
             <a:r>
               <a:rPr lang="en-US" sz="1700" dirty="0">
@@ -24960,7 +25018,7 @@
                   <a:schemeClr val="tx1"/>
                 </a:solidFill>
               </a:rPr>
-              <a:t> vraies avec le zinnenbouwer 1.1 (familles A à D).</a:t>
+              <a:t> : 10 phrases vraies avec le zinnenbouwer 1.1 (p. 8–9).</a:t>
             </a:r>
             <a:endParaRPr lang="en-US" sz="1700" dirty="0"/>
           </a:p>
@@ -25268,7 +25326,7 @@
                   <a:schemeClr val="tx1"/>
                 </a:solidFill>
               </a:rPr>
-              <a:t>Chaque séquence suit </a:t>
+              <a:t>Chaque séquence se déroule en </a:t>
             </a:r>
             <a:r>
               <a:rPr lang="en-US" sz="1800" b="1" dirty="0">
@@ -26176,7 +26234,7 @@
                   <a:schemeClr val="tx2"/>
                 </a:solidFill>
               </a:rPr>
-              <a:t>Lire son syllabus</a:t>
+              <a:t>Section 1 : quatre séquences et une synthèse</a:t>
             </a:r>
             <a:endParaRPr lang="en-US" sz="3200" dirty="0"/>
           </a:p>
@@ -26191,7 +26249,7 @@
         <p:spPr>
           <a:xfrm>
             <a:off x="548640" y="237744"/>
-            <a:ext cx="1303020" cy="310896"/>
+            <a:ext cx="822960" cy="310896"/>
           </a:xfrm>
           <a:prstGeom prst="roundRect">
             <a:avLst>
@@ -26216,7 +26274,7 @@
                   <a:schemeClr val="bg1"/>
                 </a:solidFill>
               </a:rPr>
-              <a:t>MÉTHODE</a:t>
+              <a:t>PLAN</a:t>
             </a:r>
             <a:endParaRPr lang="en-US" sz="1200" dirty="0"/>
           </a:p>
@@ -26252,1174 +26310,6 @@
                   <a:schemeClr val="accent5"/>
                 </a:solidFill>
               </a:rPr>
-              <a:t>Tout le livret</a:t>
-            </a:r>
-            <a:endParaRPr lang="en-US" sz="1200" dirty="0"/>
-          </a:p>
-        </p:txBody>
-      </p:sp>
-      <p:sp>
-        <p:nvSpPr>
-          <p:cNvPr id="6" name="Shape 3"/>
-          <p:cNvSpPr/>
-          <p:nvPr/>
-        </p:nvSpPr>
-        <p:spPr>
-          <a:xfrm>
-            <a:off x="548640" y="1554480"/>
-            <a:ext cx="5385816" cy="1104138"/>
-          </a:xfrm>
-          <a:prstGeom prst="roundRect">
-            <a:avLst>
-              <a:gd name="adj" fmla="val 4969"/>
-            </a:avLst>
-          </a:prstGeom>
-          <a:solidFill>
-            <a:schemeClr val="bg2"/>
-          </a:solidFill>
-          <a:ln w="6350">
-            <a:solidFill>
-              <a:srgbClr val="D5DCE6"/>
-            </a:solidFill>
-            <a:prstDash val="solid"/>
-          </a:ln>
-        </p:spPr>
-      </p:sp>
-      <p:sp>
-        <p:nvSpPr>
-          <p:cNvPr id="7" name="Text 4"/>
-          <p:cNvSpPr/>
-          <p:nvPr/>
-        </p:nvSpPr>
-        <p:spPr>
-          <a:xfrm>
-            <a:off x="685800" y="1932813"/>
-            <a:ext cx="1874520" cy="347472"/>
-          </a:xfrm>
-          <a:prstGeom prst="roundRect">
-            <a:avLst>
-              <a:gd name="adj" fmla="val 13158"/>
-            </a:avLst>
-          </a:prstGeom>
-          <a:solidFill>
-            <a:schemeClr val="accent3"/>
-          </a:solidFill>
-          <a:ln/>
-        </p:spPr>
-        <p:txBody>
-          <a:bodyPr wrap="square" lIns="0" tIns="0" rIns="0" bIns="0" rtlCol="0" anchor="ctr"/>
-          <a:lstStyle/>
-          <a:p>
-            <a:pPr algn="ctr" indent="0" marL="0">
-              <a:buNone/>
-            </a:pPr>
-            <a:r>
-              <a:rPr lang="en-US" sz="1100" b="1" spc="100" kern="0" dirty="0">
-                <a:solidFill>
-                  <a:schemeClr val="bg1"/>
-                </a:solidFill>
-              </a:rPr>
-              <a:t>COUCHE 1</a:t>
-            </a:r>
-            <a:endParaRPr lang="en-US" sz="1100" dirty="0"/>
-          </a:p>
-        </p:txBody>
-      </p:sp>
-      <p:sp>
-        <p:nvSpPr>
-          <p:cNvPr id="8" name="Text 5"/>
-          <p:cNvSpPr txBox="1"/>
-          <p:nvPr/>
-        </p:nvSpPr>
-        <p:spPr>
-          <a:xfrm>
-            <a:off x="2724912" y="1572768"/>
-            <a:ext cx="3099816" cy="1067562"/>
-          </a:xfrm>
-          <a:prstGeom prst="rect">
-            <a:avLst/>
-          </a:prstGeom>
-          <a:noFill/>
-          <a:ln/>
-        </p:spPr>
-        <p:txBody>
-          <a:bodyPr wrap="square" lIns="0" tIns="0" rIns="0" bIns="0" rtlCol="0" anchor="ctr"/>
-          <a:lstStyle/>
-          <a:p>
-            <a:pPr indent="0" marL="0">
-              <a:buNone/>
-            </a:pPr>
-            <a:r>
-              <a:rPr lang="en-US" sz="1800" dirty="0">
-                <a:solidFill>
-                  <a:schemeClr val="tx1"/>
-                </a:solidFill>
-              </a:rPr>
-              <a:t>Bandeau </a:t>
-            </a:r>
-            <a:r>
-              <a:rPr lang="en-US" sz="1800" b="1" dirty="0">
-                <a:solidFill>
-                  <a:schemeClr val="tx1"/>
-                </a:solidFill>
-              </a:rPr>
-              <a:t>vert</a:t>
-            </a:r>
-            <a:r>
-              <a:rPr lang="en-US" sz="1800" dirty="0">
-                <a:solidFill>
-                  <a:schemeClr val="tx1"/>
-                </a:solidFill>
-              </a:rPr>
-              <a:t> : réception intensive. On écoute, on lit, on repère.</a:t>
-            </a:r>
-            <a:endParaRPr lang="en-US" sz="1800" dirty="0"/>
-          </a:p>
-        </p:txBody>
-      </p:sp>
-      <p:sp>
-        <p:nvSpPr>
-          <p:cNvPr id="9" name="Shape 6"/>
-          <p:cNvSpPr/>
-          <p:nvPr/>
-        </p:nvSpPr>
-        <p:spPr>
-          <a:xfrm>
-            <a:off x="548640" y="2750058"/>
-            <a:ext cx="5385816" cy="1104138"/>
-          </a:xfrm>
-          <a:prstGeom prst="roundRect">
-            <a:avLst>
-              <a:gd name="adj" fmla="val 4969"/>
-            </a:avLst>
-          </a:prstGeom>
-          <a:solidFill>
-            <a:schemeClr val="bg1"/>
-          </a:solidFill>
-          <a:ln w="6350">
-            <a:solidFill>
-              <a:srgbClr val="D5DCE6"/>
-            </a:solidFill>
-            <a:prstDash val="solid"/>
-          </a:ln>
-        </p:spPr>
-      </p:sp>
-      <p:sp>
-        <p:nvSpPr>
-          <p:cNvPr id="10" name="Text 7"/>
-          <p:cNvSpPr/>
-          <p:nvPr/>
-        </p:nvSpPr>
-        <p:spPr>
-          <a:xfrm>
-            <a:off x="685800" y="3128391"/>
-            <a:ext cx="1874520" cy="347472"/>
-          </a:xfrm>
-          <a:prstGeom prst="roundRect">
-            <a:avLst>
-              <a:gd name="adj" fmla="val 13158"/>
-            </a:avLst>
-          </a:prstGeom>
-          <a:solidFill>
-            <a:schemeClr val="accent2"/>
-          </a:solidFill>
-          <a:ln/>
-        </p:spPr>
-        <p:txBody>
-          <a:bodyPr wrap="square" lIns="0" tIns="0" rIns="0" bIns="0" rtlCol="0" anchor="ctr"/>
-          <a:lstStyle/>
-          <a:p>
-            <a:pPr algn="ctr" indent="0" marL="0">
-              <a:buNone/>
-            </a:pPr>
-            <a:r>
-              <a:rPr lang="en-US" sz="1100" b="1" spc="100" kern="0" dirty="0">
-                <a:solidFill>
-                  <a:schemeClr val="bg1"/>
-                </a:solidFill>
-              </a:rPr>
-              <a:t>COUCHE 2</a:t>
-            </a:r>
-            <a:endParaRPr lang="en-US" sz="1100" dirty="0"/>
-          </a:p>
-        </p:txBody>
-      </p:sp>
-      <p:sp>
-        <p:nvSpPr>
-          <p:cNvPr id="11" name="Text 8"/>
-          <p:cNvSpPr txBox="1"/>
-          <p:nvPr/>
-        </p:nvSpPr>
-        <p:spPr>
-          <a:xfrm>
-            <a:off x="2724912" y="2768346"/>
-            <a:ext cx="3099816" cy="1067562"/>
-          </a:xfrm>
-          <a:prstGeom prst="rect">
-            <a:avLst/>
-          </a:prstGeom>
-          <a:noFill/>
-          <a:ln/>
-        </p:spPr>
-        <p:txBody>
-          <a:bodyPr wrap="square" lIns="0" tIns="0" rIns="0" bIns="0" rtlCol="0" anchor="ctr"/>
-          <a:lstStyle/>
-          <a:p>
-            <a:pPr indent="0" marL="0">
-              <a:buNone/>
-            </a:pPr>
-            <a:r>
-              <a:rPr lang="en-US" sz="1800" dirty="0">
-                <a:solidFill>
-                  <a:schemeClr val="tx1"/>
-                </a:solidFill>
-              </a:rPr>
-              <a:t>Bandeau </a:t>
-            </a:r>
-            <a:r>
-              <a:rPr lang="en-US" sz="1800" b="1" dirty="0">
-                <a:solidFill>
-                  <a:schemeClr val="tx1"/>
-                </a:solidFill>
-              </a:rPr>
-              <a:t>bleu</a:t>
-            </a:r>
-            <a:r>
-              <a:rPr lang="en-US" sz="1800" dirty="0">
-                <a:solidFill>
-                  <a:schemeClr val="tx1"/>
-                </a:solidFill>
-              </a:rPr>
-              <a:t> : production structurée, avec le zinnenbouwer </a:t>
-            </a:r>
-            <a:r>
-              <a:rPr lang="en-US" sz="1800" b="1" dirty="0">
-                <a:solidFill>
-                  <a:schemeClr val="tx1"/>
-                </a:solidFill>
-              </a:rPr>
-              <a:t>ouvert</a:t>
-            </a:r>
-            <a:r>
-              <a:rPr lang="en-US" sz="1800" dirty="0">
-                <a:solidFill>
-                  <a:schemeClr val="tx1"/>
-                </a:solidFill>
-              </a:rPr>
-              <a:t>.</a:t>
-            </a:r>
-            <a:endParaRPr lang="en-US" sz="1800" dirty="0"/>
-          </a:p>
-        </p:txBody>
-      </p:sp>
-      <p:sp>
-        <p:nvSpPr>
-          <p:cNvPr id="12" name="Shape 9"/>
-          <p:cNvSpPr/>
-          <p:nvPr/>
-        </p:nvSpPr>
-        <p:spPr>
-          <a:xfrm>
-            <a:off x="548640" y="3945636"/>
-            <a:ext cx="5385816" cy="1104138"/>
-          </a:xfrm>
-          <a:prstGeom prst="roundRect">
-            <a:avLst>
-              <a:gd name="adj" fmla="val 4969"/>
-            </a:avLst>
-          </a:prstGeom>
-          <a:solidFill>
-            <a:schemeClr val="bg2"/>
-          </a:solidFill>
-          <a:ln w="6350">
-            <a:solidFill>
-              <a:srgbClr val="D5DCE6"/>
-            </a:solidFill>
-            <a:prstDash val="solid"/>
-          </a:ln>
-        </p:spPr>
-      </p:sp>
-      <p:sp>
-        <p:nvSpPr>
-          <p:cNvPr id="13" name="Text 10"/>
-          <p:cNvSpPr/>
-          <p:nvPr/>
-        </p:nvSpPr>
-        <p:spPr>
-          <a:xfrm>
-            <a:off x="685800" y="4323969"/>
-            <a:ext cx="1874520" cy="347472"/>
-          </a:xfrm>
-          <a:prstGeom prst="roundRect">
-            <a:avLst>
-              <a:gd name="adj" fmla="val 13158"/>
-            </a:avLst>
-          </a:prstGeom>
-          <a:solidFill>
-            <a:schemeClr val="accent1"/>
-          </a:solidFill>
-          <a:ln/>
-        </p:spPr>
-        <p:txBody>
-          <a:bodyPr wrap="square" lIns="0" tIns="0" rIns="0" bIns="0" rtlCol="0" anchor="ctr"/>
-          <a:lstStyle/>
-          <a:p>
-            <a:pPr algn="ctr" indent="0" marL="0">
-              <a:buNone/>
-            </a:pPr>
-            <a:r>
-              <a:rPr lang="en-US" sz="1100" b="1" spc="100" kern="0" dirty="0">
-                <a:solidFill>
-                  <a:schemeClr val="bg1"/>
-                </a:solidFill>
-              </a:rPr>
-              <a:t>COUCHE 3</a:t>
-            </a:r>
-            <a:endParaRPr lang="en-US" sz="1100" dirty="0"/>
-          </a:p>
-        </p:txBody>
-      </p:sp>
-      <p:sp>
-        <p:nvSpPr>
-          <p:cNvPr id="14" name="Text 11"/>
-          <p:cNvSpPr txBox="1"/>
-          <p:nvPr/>
-        </p:nvSpPr>
-        <p:spPr>
-          <a:xfrm>
-            <a:off x="2724912" y="3963924"/>
-            <a:ext cx="3099816" cy="1067562"/>
-          </a:xfrm>
-          <a:prstGeom prst="rect">
-            <a:avLst/>
-          </a:prstGeom>
-          <a:noFill/>
-          <a:ln/>
-        </p:spPr>
-        <p:txBody>
-          <a:bodyPr wrap="square" lIns="0" tIns="0" rIns="0" bIns="0" rtlCol="0" anchor="ctr"/>
-          <a:lstStyle/>
-          <a:p>
-            <a:pPr indent="0" marL="0">
-              <a:buNone/>
-            </a:pPr>
-            <a:r>
-              <a:rPr lang="en-US" sz="1800" dirty="0">
-                <a:solidFill>
-                  <a:schemeClr val="tx1"/>
-                </a:solidFill>
-              </a:rPr>
-              <a:t>Bandeau </a:t>
-            </a:r>
-            <a:r>
-              <a:rPr lang="en-US" sz="1800" b="1" dirty="0">
-                <a:solidFill>
-                  <a:schemeClr val="tx1"/>
-                </a:solidFill>
-              </a:rPr>
-              <a:t>jaune</a:t>
-            </a:r>
-            <a:r>
-              <a:rPr lang="en-US" sz="1800" dirty="0">
-                <a:solidFill>
-                  <a:schemeClr val="tx1"/>
-                </a:solidFill>
-              </a:rPr>
-              <a:t> : fluidité, zinnenbouwer </a:t>
-            </a:r>
-            <a:r>
-              <a:rPr lang="en-US" sz="1800" b="1" dirty="0">
-                <a:solidFill>
-                  <a:schemeClr val="tx1"/>
-                </a:solidFill>
-              </a:rPr>
-              <a:t>fermé</a:t>
-            </a:r>
-            <a:r>
-              <a:rPr lang="en-US" sz="1800" dirty="0">
-                <a:solidFill>
-                  <a:schemeClr val="tx1"/>
-                </a:solidFill>
-              </a:rPr>
-              <a:t>, chronomètre.</a:t>
-            </a:r>
-            <a:endParaRPr lang="en-US" sz="1800" dirty="0"/>
-          </a:p>
-        </p:txBody>
-      </p:sp>
-      <p:sp>
-        <p:nvSpPr>
-          <p:cNvPr id="15" name="Shape 12"/>
-          <p:cNvSpPr/>
-          <p:nvPr/>
-        </p:nvSpPr>
-        <p:spPr>
-          <a:xfrm>
-            <a:off x="548640" y="5141214"/>
-            <a:ext cx="5385816" cy="1104138"/>
-          </a:xfrm>
-          <a:prstGeom prst="roundRect">
-            <a:avLst>
-              <a:gd name="adj" fmla="val 4969"/>
-            </a:avLst>
-          </a:prstGeom>
-          <a:solidFill>
-            <a:schemeClr val="bg1"/>
-          </a:solidFill>
-          <a:ln w="6350">
-            <a:solidFill>
-              <a:srgbClr val="D5DCE6"/>
-            </a:solidFill>
-            <a:prstDash val="solid"/>
-          </a:ln>
-        </p:spPr>
-      </p:sp>
-      <p:sp>
-        <p:nvSpPr>
-          <p:cNvPr id="16" name="Text 13"/>
-          <p:cNvSpPr/>
-          <p:nvPr/>
-        </p:nvSpPr>
-        <p:spPr>
-          <a:xfrm>
-            <a:off x="685800" y="5519547"/>
-            <a:ext cx="1874520" cy="347472"/>
-          </a:xfrm>
-          <a:prstGeom prst="roundRect">
-            <a:avLst>
-              <a:gd name="adj" fmla="val 13158"/>
-            </a:avLst>
-          </a:prstGeom>
-          <a:solidFill>
-            <a:schemeClr val="tx2"/>
-          </a:solidFill>
-          <a:ln/>
-        </p:spPr>
-        <p:txBody>
-          <a:bodyPr wrap="square" lIns="0" tIns="0" rIns="0" bIns="0" rtlCol="0" anchor="ctr"/>
-          <a:lstStyle/>
-          <a:p>
-            <a:pPr algn="ctr" indent="0" marL="0">
-              <a:buNone/>
-            </a:pPr>
-            <a:r>
-              <a:rPr lang="en-US" sz="1100" b="1" spc="100" kern="0" dirty="0">
-                <a:solidFill>
-                  <a:schemeClr val="bg1"/>
-                </a:solidFill>
-              </a:rPr>
-              <a:t>ZINNENBOUWER</a:t>
-            </a:r>
-            <a:endParaRPr lang="en-US" sz="1100" dirty="0"/>
-          </a:p>
-        </p:txBody>
-      </p:sp>
-      <p:sp>
-        <p:nvSpPr>
-          <p:cNvPr id="17" name="Text 14"/>
-          <p:cNvSpPr txBox="1"/>
-          <p:nvPr/>
-        </p:nvSpPr>
-        <p:spPr>
-          <a:xfrm>
-            <a:off x="2724912" y="5159502"/>
-            <a:ext cx="3099816" cy="1067562"/>
-          </a:xfrm>
-          <a:prstGeom prst="rect">
-            <a:avLst/>
-          </a:prstGeom>
-          <a:noFill/>
-          <a:ln/>
-        </p:spPr>
-        <p:txBody>
-          <a:bodyPr wrap="square" lIns="0" tIns="0" rIns="0" bIns="0" rtlCol="0" anchor="ctr"/>
-          <a:lstStyle/>
-          <a:p>
-            <a:pPr indent="0" marL="0">
-              <a:buNone/>
-            </a:pPr>
-            <a:r>
-              <a:rPr lang="en-US" sz="1800" dirty="0">
-                <a:solidFill>
-                  <a:schemeClr val="tx1"/>
-                </a:solidFill>
-              </a:rPr>
-              <a:t>Tableau de </a:t>
-            </a:r>
-            <a:r>
-              <a:rPr lang="en-US" sz="1800" b="1" dirty="0">
-                <a:solidFill>
-                  <a:schemeClr val="tx1"/>
-                </a:solidFill>
-              </a:rPr>
-              <a:t>familles de phrases</a:t>
-            </a:r>
-            <a:r>
-              <a:rPr lang="en-US" sz="1800" dirty="0">
-                <a:solidFill>
-                  <a:schemeClr val="tx1"/>
-                </a:solidFill>
-              </a:rPr>
-              <a:t> : on prend un bloc par colonne.</a:t>
-            </a:r>
-            <a:endParaRPr lang="en-US" sz="1800" dirty="0"/>
-          </a:p>
-        </p:txBody>
-      </p:sp>
-      <p:sp>
-        <p:nvSpPr>
-          <p:cNvPr id="18" name="Shape 15"/>
-          <p:cNvSpPr/>
-          <p:nvPr/>
-        </p:nvSpPr>
-        <p:spPr>
-          <a:xfrm>
-            <a:off x="6254496" y="1554480"/>
-            <a:ext cx="5385816" cy="1104138"/>
-          </a:xfrm>
-          <a:prstGeom prst="roundRect">
-            <a:avLst>
-              <a:gd name="adj" fmla="val 4969"/>
-            </a:avLst>
-          </a:prstGeom>
-          <a:solidFill>
-            <a:schemeClr val="bg2"/>
-          </a:solidFill>
-          <a:ln w="6350">
-            <a:solidFill>
-              <a:srgbClr val="D5DCE6"/>
-            </a:solidFill>
-            <a:prstDash val="solid"/>
-          </a:ln>
-        </p:spPr>
-      </p:sp>
-      <p:sp>
-        <p:nvSpPr>
-          <p:cNvPr id="19" name="Text 16"/>
-          <p:cNvSpPr/>
-          <p:nvPr/>
-        </p:nvSpPr>
-        <p:spPr>
-          <a:xfrm>
-            <a:off x="6391656" y="1932813"/>
-            <a:ext cx="1874520" cy="347472"/>
-          </a:xfrm>
-          <a:prstGeom prst="roundRect">
-            <a:avLst>
-              <a:gd name="adj" fmla="val 13158"/>
-            </a:avLst>
-          </a:prstGeom>
-          <a:solidFill>
-            <a:schemeClr val="accent6"/>
-          </a:solidFill>
-          <a:ln/>
-        </p:spPr>
-        <p:txBody>
-          <a:bodyPr wrap="square" lIns="0" tIns="0" rIns="0" bIns="0" rtlCol="0" anchor="ctr"/>
-          <a:lstStyle/>
-          <a:p>
-            <a:pPr algn="ctr" indent="0" marL="0">
-              <a:buNone/>
-            </a:pPr>
-            <a:r>
-              <a:rPr lang="en-US" sz="1100" b="1" spc="100" kern="0" dirty="0">
-                <a:solidFill>
-                  <a:schemeClr val="bg1"/>
-                </a:solidFill>
-              </a:rPr>
-              <a:t>EXTRA</a:t>
-            </a:r>
-            <a:endParaRPr lang="en-US" sz="1100" dirty="0"/>
-          </a:p>
-        </p:txBody>
-      </p:sp>
-      <p:sp>
-        <p:nvSpPr>
-          <p:cNvPr id="20" name="Text 17"/>
-          <p:cNvSpPr txBox="1"/>
-          <p:nvPr/>
-        </p:nvSpPr>
-        <p:spPr>
-          <a:xfrm>
-            <a:off x="8430768" y="1572768"/>
-            <a:ext cx="3099816" cy="1067562"/>
-          </a:xfrm>
-          <a:prstGeom prst="rect">
-            <a:avLst/>
-          </a:prstGeom>
-          <a:noFill/>
-          <a:ln/>
-        </p:spPr>
-        <p:txBody>
-          <a:bodyPr wrap="square" lIns="0" tIns="0" rIns="0" bIns="0" rtlCol="0" anchor="ctr"/>
-          <a:lstStyle/>
-          <a:p>
-            <a:pPr indent="0" marL="0">
-              <a:buNone/>
-            </a:pPr>
-            <a:r>
-              <a:rPr lang="en-US" sz="1800" dirty="0">
-                <a:solidFill>
-                  <a:schemeClr val="tx1"/>
-                </a:solidFill>
-              </a:rPr>
-              <a:t>Exercice </a:t>
-            </a:r>
-            <a:r>
-              <a:rPr lang="en-US" sz="1800" b="1" dirty="0">
-                <a:solidFill>
-                  <a:schemeClr val="tx1"/>
-                </a:solidFill>
-              </a:rPr>
-              <a:t>supplémentaire</a:t>
-            </a:r>
-            <a:r>
-              <a:rPr lang="en-US" sz="1800" dirty="0">
-                <a:solidFill>
-                  <a:schemeClr val="tx1"/>
-                </a:solidFill>
-              </a:rPr>
-              <a:t> (mots composés, pronoms…).</a:t>
-            </a:r>
-            <a:endParaRPr lang="en-US" sz="1800" dirty="0"/>
-          </a:p>
-        </p:txBody>
-      </p:sp>
-      <p:sp>
-        <p:nvSpPr>
-          <p:cNvPr id="21" name="Shape 18"/>
-          <p:cNvSpPr/>
-          <p:nvPr/>
-        </p:nvSpPr>
-        <p:spPr>
-          <a:xfrm>
-            <a:off x="6254496" y="2750058"/>
-            <a:ext cx="5385816" cy="1104138"/>
-          </a:xfrm>
-          <a:prstGeom prst="roundRect">
-            <a:avLst>
-              <a:gd name="adj" fmla="val 4969"/>
-            </a:avLst>
-          </a:prstGeom>
-          <a:solidFill>
-            <a:schemeClr val="bg1"/>
-          </a:solidFill>
-          <a:ln w="6350">
-            <a:solidFill>
-              <a:srgbClr val="D5DCE6"/>
-            </a:solidFill>
-            <a:prstDash val="solid"/>
-          </a:ln>
-        </p:spPr>
-      </p:sp>
-      <p:sp>
-        <p:nvSpPr>
-          <p:cNvPr id="22" name="Text 19"/>
-          <p:cNvSpPr/>
-          <p:nvPr/>
-        </p:nvSpPr>
-        <p:spPr>
-          <a:xfrm>
-            <a:off x="6391656" y="3128391"/>
-            <a:ext cx="1874520" cy="347472"/>
-          </a:xfrm>
-          <a:prstGeom prst="roundRect">
-            <a:avLst>
-              <a:gd name="adj" fmla="val 13158"/>
-            </a:avLst>
-          </a:prstGeom>
-          <a:solidFill>
-            <a:schemeClr val="accent1"/>
-          </a:solidFill>
-          <a:ln/>
-        </p:spPr>
-        <p:txBody>
-          <a:bodyPr wrap="square" lIns="0" tIns="0" rIns="0" bIns="0" rtlCol="0" anchor="ctr"/>
-          <a:lstStyle/>
-          <a:p>
-            <a:pPr algn="ctr" indent="0" marL="0">
-              <a:buNone/>
-            </a:pPr>
-            <a:r>
-              <a:rPr lang="en-US" sz="1100" b="1" spc="100" kern="0" dirty="0">
-                <a:solidFill>
-                  <a:schemeClr val="bg1"/>
-                </a:solidFill>
-              </a:rPr>
-              <a:t>JIJ NU!</a:t>
-            </a:r>
-            <a:endParaRPr lang="en-US" sz="1100" dirty="0"/>
-          </a:p>
-        </p:txBody>
-      </p:sp>
-      <p:sp>
-        <p:nvSpPr>
-          <p:cNvPr id="23" name="Text 20"/>
-          <p:cNvSpPr txBox="1"/>
-          <p:nvPr/>
-        </p:nvSpPr>
-        <p:spPr>
-          <a:xfrm>
-            <a:off x="8430768" y="2768346"/>
-            <a:ext cx="3099816" cy="1067562"/>
-          </a:xfrm>
-          <a:prstGeom prst="rect">
-            <a:avLst/>
-          </a:prstGeom>
-          <a:noFill/>
-          <a:ln/>
-        </p:spPr>
-        <p:txBody>
-          <a:bodyPr wrap="square" lIns="0" tIns="0" rIns="0" bIns="0" rtlCol="0" anchor="ctr"/>
-          <a:lstStyle/>
-          <a:p>
-            <a:pPr indent="0" marL="0">
-              <a:buNone/>
-            </a:pPr>
-            <a:r>
-              <a:rPr lang="en-US" sz="1800" dirty="0">
-                <a:solidFill>
-                  <a:schemeClr val="tx1"/>
-                </a:solidFill>
-              </a:rPr>
-              <a:t>« </a:t>
-            </a:r>
-            <a:r>
-              <a:rPr lang="en-US" sz="1800" b="1" dirty="0">
-                <a:solidFill>
-                  <a:schemeClr val="tx1"/>
-                </a:solidFill>
-              </a:rPr>
-              <a:t>À toi !</a:t>
-            </a:r>
-            <a:r>
-              <a:rPr lang="en-US" sz="1800" dirty="0">
-                <a:solidFill>
-                  <a:schemeClr val="tx1"/>
-                </a:solidFill>
-              </a:rPr>
-              <a:t> » : mise en situation orale en fin de séquence.</a:t>
-            </a:r>
-            <a:endParaRPr lang="en-US" sz="1800" dirty="0"/>
-          </a:p>
-        </p:txBody>
-      </p:sp>
-      <p:sp>
-        <p:nvSpPr>
-          <p:cNvPr id="24" name="Shape 21"/>
-          <p:cNvSpPr/>
-          <p:nvPr/>
-        </p:nvSpPr>
-        <p:spPr>
-          <a:xfrm>
-            <a:off x="6254496" y="3945636"/>
-            <a:ext cx="5385816" cy="1104138"/>
-          </a:xfrm>
-          <a:prstGeom prst="roundRect">
-            <a:avLst>
-              <a:gd name="adj" fmla="val 4969"/>
-            </a:avLst>
-          </a:prstGeom>
-          <a:solidFill>
-            <a:schemeClr val="bg2"/>
-          </a:solidFill>
-          <a:ln w="6350">
-            <a:solidFill>
-              <a:srgbClr val="D5DCE6"/>
-            </a:solidFill>
-            <a:prstDash val="solid"/>
-          </a:ln>
-        </p:spPr>
-      </p:sp>
-      <p:sp>
-        <p:nvSpPr>
-          <p:cNvPr id="25" name="Text 22"/>
-          <p:cNvSpPr/>
-          <p:nvPr/>
-        </p:nvSpPr>
-        <p:spPr>
-          <a:xfrm>
-            <a:off x="6391656" y="4323969"/>
-            <a:ext cx="1874520" cy="347472"/>
-          </a:xfrm>
-          <a:prstGeom prst="roundRect">
-            <a:avLst>
-              <a:gd name="adj" fmla="val 13158"/>
-            </a:avLst>
-          </a:prstGeom>
-          <a:solidFill>
-            <a:schemeClr val="accent4"/>
-          </a:solidFill>
-          <a:ln/>
-        </p:spPr>
-        <p:txBody>
-          <a:bodyPr wrap="square" lIns="0" tIns="0" rIns="0" bIns="0" rtlCol="0" anchor="ctr"/>
-          <a:lstStyle/>
-          <a:p>
-            <a:pPr algn="ctr" indent="0" marL="0">
-              <a:buNone/>
-            </a:pPr>
-            <a:r>
-              <a:rPr lang="en-US" sz="1100" b="1" spc="100" kern="0" dirty="0">
-                <a:solidFill>
-                  <a:schemeClr val="bg1"/>
-                </a:solidFill>
-              </a:rPr>
-              <a:t>KLANKMOMENT</a:t>
-            </a:r>
-            <a:endParaRPr lang="en-US" sz="1100" dirty="0"/>
-          </a:p>
-        </p:txBody>
-      </p:sp>
-      <p:sp>
-        <p:nvSpPr>
-          <p:cNvPr id="26" name="Text 23"/>
-          <p:cNvSpPr txBox="1"/>
-          <p:nvPr/>
-        </p:nvSpPr>
-        <p:spPr>
-          <a:xfrm>
-            <a:off x="8430768" y="3963924"/>
-            <a:ext cx="3099816" cy="1067562"/>
-          </a:xfrm>
-          <a:prstGeom prst="rect">
-            <a:avLst/>
-          </a:prstGeom>
-          <a:noFill/>
-          <a:ln/>
-        </p:spPr>
-        <p:txBody>
-          <a:bodyPr wrap="square" lIns="0" tIns="0" rIns="0" bIns="0" rtlCol="0" anchor="ctr"/>
-          <a:lstStyle/>
-          <a:p>
-            <a:pPr indent="0" marL="0">
-              <a:buNone/>
-            </a:pPr>
-            <a:r>
-              <a:rPr lang="en-US" sz="1800" dirty="0">
-                <a:solidFill>
-                  <a:schemeClr val="tx1"/>
-                </a:solidFill>
-              </a:rPr>
-              <a:t>Moment de </a:t>
-            </a:r>
-            <a:r>
-              <a:rPr lang="en-US" sz="1800" b="1" dirty="0">
-                <a:solidFill>
-                  <a:schemeClr val="tx1"/>
-                </a:solidFill>
-              </a:rPr>
-              <a:t>prononciation</a:t>
-            </a:r>
-            <a:r>
-              <a:rPr lang="en-US" sz="1800" dirty="0">
-                <a:solidFill>
-                  <a:schemeClr val="tx1"/>
-                </a:solidFill>
-              </a:rPr>
-              <a:t> (g, ch, ’s…).</a:t>
-            </a:r>
-            <a:endParaRPr lang="en-US" sz="1800" dirty="0"/>
-          </a:p>
-        </p:txBody>
-      </p:sp>
-      <p:sp>
-        <p:nvSpPr>
-          <p:cNvPr id="27" name="Shape 24"/>
-          <p:cNvSpPr/>
-          <p:nvPr/>
-        </p:nvSpPr>
-        <p:spPr>
-          <a:xfrm>
-            <a:off x="6254496" y="5141214"/>
-            <a:ext cx="5385816" cy="1104138"/>
-          </a:xfrm>
-          <a:prstGeom prst="roundRect">
-            <a:avLst>
-              <a:gd name="adj" fmla="val 4969"/>
-            </a:avLst>
-          </a:prstGeom>
-          <a:solidFill>
-            <a:schemeClr val="bg1"/>
-          </a:solidFill>
-          <a:ln w="6350">
-            <a:solidFill>
-              <a:srgbClr val="D5DCE6"/>
-            </a:solidFill>
-            <a:prstDash val="solid"/>
-          </a:ln>
-        </p:spPr>
-      </p:sp>
-      <p:sp>
-        <p:nvSpPr>
-          <p:cNvPr id="28" name="Text 25"/>
-          <p:cNvSpPr/>
-          <p:nvPr/>
-        </p:nvSpPr>
-        <p:spPr>
-          <a:xfrm>
-            <a:off x="6391656" y="5519547"/>
-            <a:ext cx="1874520" cy="347472"/>
-          </a:xfrm>
-          <a:prstGeom prst="roundRect">
-            <a:avLst>
-              <a:gd name="adj" fmla="val 13158"/>
-            </a:avLst>
-          </a:prstGeom>
-          <a:solidFill>
-            <a:schemeClr val="tx2"/>
-          </a:solidFill>
-          <a:ln/>
-        </p:spPr>
-        <p:txBody>
-          <a:bodyPr wrap="square" lIns="0" tIns="0" rIns="0" bIns="0" rtlCol="0" anchor="ctr"/>
-          <a:lstStyle/>
-          <a:p>
-            <a:pPr algn="ctr" indent="0" marL="0">
-              <a:buNone/>
-            </a:pPr>
-            <a:r>
-              <a:rPr lang="en-US" sz="1100" b="1" spc="100" kern="0" dirty="0">
-                <a:solidFill>
-                  <a:schemeClr val="bg1"/>
-                </a:solidFill>
-              </a:rPr>
-              <a:t>+ BONUS</a:t>
-            </a:r>
-            <a:endParaRPr lang="en-US" sz="1100" dirty="0"/>
-          </a:p>
-        </p:txBody>
-      </p:sp>
-      <p:sp>
-        <p:nvSpPr>
-          <p:cNvPr id="29" name="Text 26"/>
-          <p:cNvSpPr txBox="1"/>
-          <p:nvPr/>
-        </p:nvSpPr>
-        <p:spPr>
-          <a:xfrm>
-            <a:off x="8430768" y="5159502"/>
-            <a:ext cx="3099816" cy="1067562"/>
-          </a:xfrm>
-          <a:prstGeom prst="rect">
-            <a:avLst/>
-          </a:prstGeom>
-          <a:noFill/>
-          <a:ln/>
-        </p:spPr>
-        <p:txBody>
-          <a:bodyPr wrap="square" lIns="0" tIns="0" rIns="0" bIns="0" rtlCol="0" anchor="ctr"/>
-          <a:lstStyle/>
-          <a:p>
-            <a:pPr indent="0" marL="0">
-              <a:buNone/>
-            </a:pPr>
-            <a:r>
-              <a:rPr lang="en-US" sz="1800" dirty="0">
-                <a:solidFill>
-                  <a:schemeClr val="tx1"/>
-                </a:solidFill>
-              </a:rPr>
-              <a:t>Exercice </a:t>
-            </a:r>
-            <a:r>
-              <a:rPr lang="en-US" sz="1800" b="1" dirty="0">
-                <a:solidFill>
-                  <a:schemeClr val="tx1"/>
-                </a:solidFill>
-              </a:rPr>
-              <a:t>ajouté</a:t>
-            </a:r>
-            <a:r>
-              <a:rPr lang="en-US" sz="1800" dirty="0">
-                <a:solidFill>
-                  <a:schemeClr val="tx1"/>
-                </a:solidFill>
-              </a:rPr>
-              <a:t> au tableau, hors syllabus.</a:t>
-            </a:r>
-            <a:endParaRPr lang="en-US" sz="1800" dirty="0"/>
-          </a:p>
-        </p:txBody>
-      </p:sp>
-      <p:sp>
-        <p:nvSpPr>
-          <p:cNvPr id="25" name="Slide Number Placeholder 0"/>
-          <p:cNvSpPr>
-            <a:spLocks noGrp="1"/>
-          </p:cNvSpPr>
-          <p:nvPr>
-            <p:ph type="sldNum" sz="quarter" idx="4294967295"/>
-          </p:nvPr>
-        </p:nvSpPr>
-        <p:spPr>
-          <a:xfrm>
-            <a:off x="11091672" y="6446520"/>
-            <a:ext cx="548640" cy="274320"/>
-          </a:xfrm>
-          <a:prstGeom prst="rect">
-            <a:avLst/>
-          </a:prstGeom>
-          <a:extLst>
-            <a:ext uri="{C572A759-6A51-4108-AA02-DFA0A04FC94B}">
-              <ma14:wrappingTextBoxFlag xmlns:ma14="http://schemas.microsoft.com/office/mac/drawingml/2011/main" val="0"/>
-            </a:ext>
-          </a:extLst>
-        </p:spPr>
-        <p:txBody>
-          <a:bodyPr/>
-          <a:lstStyle>
-            <a:lvl1pPr>
-              <a:defRPr sz="1000">
-                <a:solidFill>
-                  <a:srgbClr val="4A5A70"/>
-                </a:solidFill>
-              </a:defRPr>
-            </a:lvl1pPr>
-          </a:lstStyle>
-          <a:p>
-            <a:pPr algn="r"/>
-            <a:fld id="{F7021451-1387-4CA6-816F-3879F97B5CBC}" type="slidenum">
-              <a:rPr b="0" lang="en-US"/>
-              <a:t>4</a:t>
-            </a:fld>
-            <a:endParaRPr lang="en-US"/>
-          </a:p>
-        </p:txBody>
-      </p:sp>
-    </p:spTree>
-  </p:cSld>
-  <p:clrMapOvr>
-    <a:masterClrMapping/>
-  </p:clrMapOvr>
-</p:sld>
-</file>
-
-<file path=ppt/slides/slide5.xml><?xml version="1.0" encoding="utf-8"?>
-<p:sld xmlns:a="http://schemas.openxmlformats.org/drawingml/2006/main" xmlns:r="http://schemas.openxmlformats.org/officeDocument/2006/relationships" xmlns:p="http://schemas.openxmlformats.org/presentationml/2006/main">
-  <p:cSld name="Slide 5">
-    <p:spTree>
-      <p:nvGrpSpPr>
-        <p:cNvPr id="1" name=""/>
-        <p:cNvGrpSpPr/>
-        <p:nvPr/>
-      </p:nvGrpSpPr>
-      <p:grpSpPr>
-        <a:xfrm>
-          <a:off x="0" y="0"/>
-          <a:ext cx="0" cy="0"/>
-          <a:chOff x="0" y="0"/>
-          <a:chExt cx="0" cy="0"/>
-        </a:xfrm>
-      </p:grpSpPr>
-      <p:sp>
-        <p:nvSpPr>
-          <p:cNvPr id="2" name="Text 1"/>
-          <p:cNvSpPr/>
-          <p:nvPr>
-            <p:ph idx="101" type="title" hasCustomPrompt="1"/>
-          </p:nvPr>
-        </p:nvSpPr>
-        <p:spPr>
-          <a:xfrm>
-            <a:off x="548640" y="621792"/>
-            <a:ext cx="11091672" cy="713232"/>
-          </a:xfrm>
-          <a:prstGeom prst="rect">
-            <a:avLst/>
-          </a:prstGeom>
-          <a:noFill/>
-          <a:ln/>
-        </p:spPr>
-        <p:txBody>
-          <a:bodyPr wrap="square" lIns="0" tIns="0" rIns="0" bIns="0" rtlCol="0" anchor="ctr"/>
-          <a:lstStyle/>
-          <a:p>
-            <a:pPr algn="l" indent="0" marL="0">
-              <a:buNone/>
-            </a:pPr>
-            <a:r>
-              <a:rPr lang="en-US" sz="3200" b="1" dirty="0">
-                <a:solidFill>
-                  <a:schemeClr val="tx2"/>
-                </a:solidFill>
-              </a:rPr>
-              <a:t>Section 1 : quatre séquences et une synthèse</a:t>
-            </a:r>
-            <a:endParaRPr lang="en-US" sz="3200" dirty="0"/>
-          </a:p>
-        </p:txBody>
-      </p:sp>
-      <p:sp>
-        <p:nvSpPr>
-          <p:cNvPr id="3" name="tag"/>
-          <p:cNvSpPr/>
-          <p:nvPr/>
-        </p:nvSpPr>
-        <p:spPr>
-          <a:xfrm>
-            <a:off x="548640" y="237744"/>
-            <a:ext cx="822960" cy="310896"/>
-          </a:xfrm>
-          <a:prstGeom prst="roundRect">
-            <a:avLst>
-              <a:gd name="adj" fmla="val 14706"/>
-            </a:avLst>
-          </a:prstGeom>
-          <a:solidFill>
-            <a:schemeClr val="accent5"/>
-          </a:solidFill>
-          <a:ln/>
-        </p:spPr>
-        <p:txBody>
-          <a:bodyPr wrap="square" lIns="0" tIns="0" rIns="0" bIns="0" rtlCol="0" anchor="ctr"/>
-          <a:lstStyle/>
-          <a:p>
-            <a:pPr algn="ctr" indent="0" marL="0">
-              <a:buNone/>
-            </a:pPr>
-            <a:r>
-              <a:rPr lang="en-US" sz="1200" b="1" spc="100" kern="0" dirty="0">
-                <a:solidFill>
-                  <a:schemeClr val="bg1"/>
-                </a:solidFill>
-              </a:rPr>
-              <a:t>PLAN</a:t>
-            </a:r>
-            <a:endParaRPr lang="en-US" sz="1200" dirty="0"/>
-          </a:p>
-        </p:txBody>
-      </p:sp>
-      <p:sp>
-        <p:nvSpPr>
-          <p:cNvPr id="4" name="Text 2"/>
-          <p:cNvSpPr txBox="1"/>
-          <p:nvPr/>
-        </p:nvSpPr>
-        <p:spPr>
-          <a:xfrm>
-            <a:off x="8897112" y="219456"/>
-            <a:ext cx="2743200" cy="347472"/>
-          </a:xfrm>
-          <a:prstGeom prst="rect">
-            <a:avLst/>
-          </a:prstGeom>
-          <a:noFill/>
-          <a:ln/>
-        </p:spPr>
-        <p:txBody>
-          <a:bodyPr wrap="square" lIns="0" tIns="0" rIns="0" bIns="0" rtlCol="0" anchor="ctr"/>
-          <a:lstStyle/>
-          <a:p>
-            <a:pPr algn="r" indent="0" marL="0">
-              <a:buNone/>
-            </a:pPr>
-            <a:r>
-              <a:rPr lang="en-US" sz="1200" i="1" dirty="0">
-                <a:solidFill>
-                  <a:schemeClr val="accent5"/>
-                </a:solidFill>
-              </a:rPr>
               <a:t>Livret p. ii</a:t>
             </a:r>
             <a:endParaRPr lang="en-US" sz="1200" dirty="0"/>
@@ -27428,7 +26318,7 @@
       </p:sp>
       <p:graphicFrame>
         <p:nvGraphicFramePr>
-          <p:cNvPr id="6" name="Table 0"/>
+          <p:cNvPr id="5" name="Table 0"/>
           <p:cNvGraphicFramePr>
             <a:graphicFrameLocks noGrp="1"/>
           </p:cNvGraphicFramePr>
@@ -29376,6 +28266,1174 @@
             <a:pPr algn="r"/>
             <a:fld id="{F7021451-1387-4CA6-816F-3879F97B5CBC}" type="slidenum">
               <a:rPr b="0" lang="en-US"/>
+              <a:t>4</a:t>
+            </a:fld>
+            <a:endParaRPr lang="en-US"/>
+          </a:p>
+        </p:txBody>
+      </p:sp>
+    </p:spTree>
+  </p:cSld>
+  <p:clrMapOvr>
+    <a:masterClrMapping/>
+  </p:clrMapOvr>
+</p:sld>
+</file>
+
+<file path=ppt/slides/slide5.xml><?xml version="1.0" encoding="utf-8"?>
+<p:sld xmlns:a="http://schemas.openxmlformats.org/drawingml/2006/main" xmlns:r="http://schemas.openxmlformats.org/officeDocument/2006/relationships" xmlns:p="http://schemas.openxmlformats.org/presentationml/2006/main">
+  <p:cSld name="Slide 5">
+    <p:spTree>
+      <p:nvGrpSpPr>
+        <p:cNvPr id="1" name=""/>
+        <p:cNvGrpSpPr/>
+        <p:nvPr/>
+      </p:nvGrpSpPr>
+      <p:grpSpPr>
+        <a:xfrm>
+          <a:off x="0" y="0"/>
+          <a:ext cx="0" cy="0"/>
+          <a:chOff x="0" y="0"/>
+          <a:chExt cx="0" cy="0"/>
+        </a:xfrm>
+      </p:grpSpPr>
+      <p:sp>
+        <p:nvSpPr>
+          <p:cNvPr id="2" name="Text 1"/>
+          <p:cNvSpPr/>
+          <p:nvPr>
+            <p:ph idx="101" type="title" hasCustomPrompt="1"/>
+          </p:nvPr>
+        </p:nvSpPr>
+        <p:spPr>
+          <a:xfrm>
+            <a:off x="548640" y="621792"/>
+            <a:ext cx="11091672" cy="713232"/>
+          </a:xfrm>
+          <a:prstGeom prst="rect">
+            <a:avLst/>
+          </a:prstGeom>
+          <a:noFill/>
+          <a:ln/>
+        </p:spPr>
+        <p:txBody>
+          <a:bodyPr wrap="square" lIns="0" tIns="0" rIns="0" bIns="0" rtlCol="0" anchor="ctr"/>
+          <a:lstStyle/>
+          <a:p>
+            <a:pPr algn="l" indent="0" marL="0">
+              <a:buNone/>
+            </a:pPr>
+            <a:r>
+              <a:rPr lang="en-US" sz="3200" b="1" dirty="0">
+                <a:solidFill>
+                  <a:schemeClr val="tx2"/>
+                </a:solidFill>
+              </a:rPr>
+              <a:t>Lire son syllabus</a:t>
+            </a:r>
+            <a:endParaRPr lang="en-US" sz="3200" dirty="0"/>
+          </a:p>
+        </p:txBody>
+      </p:sp>
+      <p:sp>
+        <p:nvSpPr>
+          <p:cNvPr id="3" name="tag"/>
+          <p:cNvSpPr/>
+          <p:nvPr/>
+        </p:nvSpPr>
+        <p:spPr>
+          <a:xfrm>
+            <a:off x="548640" y="237744"/>
+            <a:ext cx="1303020" cy="310896"/>
+          </a:xfrm>
+          <a:prstGeom prst="roundRect">
+            <a:avLst>
+              <a:gd name="adj" fmla="val 14706"/>
+            </a:avLst>
+          </a:prstGeom>
+          <a:solidFill>
+            <a:schemeClr val="accent5"/>
+          </a:solidFill>
+          <a:ln/>
+        </p:spPr>
+        <p:txBody>
+          <a:bodyPr wrap="square" lIns="0" tIns="0" rIns="0" bIns="0" rtlCol="0" anchor="ctr"/>
+          <a:lstStyle/>
+          <a:p>
+            <a:pPr algn="ctr" indent="0" marL="0">
+              <a:buNone/>
+            </a:pPr>
+            <a:r>
+              <a:rPr lang="en-US" sz="1200" b="1" spc="100" kern="0" dirty="0">
+                <a:solidFill>
+                  <a:schemeClr val="bg1"/>
+                </a:solidFill>
+              </a:rPr>
+              <a:t>MÉTHODE</a:t>
+            </a:r>
+            <a:endParaRPr lang="en-US" sz="1200" dirty="0"/>
+          </a:p>
+        </p:txBody>
+      </p:sp>
+      <p:sp>
+        <p:nvSpPr>
+          <p:cNvPr id="4" name="Text 2"/>
+          <p:cNvSpPr txBox="1"/>
+          <p:nvPr/>
+        </p:nvSpPr>
+        <p:spPr>
+          <a:xfrm>
+            <a:off x="8897112" y="219456"/>
+            <a:ext cx="2743200" cy="347472"/>
+          </a:xfrm>
+          <a:prstGeom prst="rect">
+            <a:avLst/>
+          </a:prstGeom>
+          <a:noFill/>
+          <a:ln/>
+        </p:spPr>
+        <p:txBody>
+          <a:bodyPr wrap="square" lIns="0" tIns="0" rIns="0" bIns="0" rtlCol="0" anchor="ctr"/>
+          <a:lstStyle/>
+          <a:p>
+            <a:pPr algn="r" indent="0" marL="0">
+              <a:buNone/>
+            </a:pPr>
+            <a:r>
+              <a:rPr lang="en-US" sz="1200" i="1" dirty="0">
+                <a:solidFill>
+                  <a:schemeClr val="accent5"/>
+                </a:solidFill>
+              </a:rPr>
+              <a:t>Tout le livret</a:t>
+            </a:r>
+            <a:endParaRPr lang="en-US" sz="1200" dirty="0"/>
+          </a:p>
+        </p:txBody>
+      </p:sp>
+      <p:sp>
+        <p:nvSpPr>
+          <p:cNvPr id="6" name="Shape 3"/>
+          <p:cNvSpPr/>
+          <p:nvPr/>
+        </p:nvSpPr>
+        <p:spPr>
+          <a:xfrm>
+            <a:off x="548640" y="1554480"/>
+            <a:ext cx="5385816" cy="1104138"/>
+          </a:xfrm>
+          <a:prstGeom prst="roundRect">
+            <a:avLst>
+              <a:gd name="adj" fmla="val 4969"/>
+            </a:avLst>
+          </a:prstGeom>
+          <a:solidFill>
+            <a:schemeClr val="bg2"/>
+          </a:solidFill>
+          <a:ln w="6350">
+            <a:solidFill>
+              <a:srgbClr val="D5DCE6"/>
+            </a:solidFill>
+            <a:prstDash val="solid"/>
+          </a:ln>
+        </p:spPr>
+      </p:sp>
+      <p:sp>
+        <p:nvSpPr>
+          <p:cNvPr id="7" name="Text 4"/>
+          <p:cNvSpPr/>
+          <p:nvPr/>
+        </p:nvSpPr>
+        <p:spPr>
+          <a:xfrm>
+            <a:off x="685800" y="1932813"/>
+            <a:ext cx="1874520" cy="347472"/>
+          </a:xfrm>
+          <a:prstGeom prst="roundRect">
+            <a:avLst>
+              <a:gd name="adj" fmla="val 13158"/>
+            </a:avLst>
+          </a:prstGeom>
+          <a:solidFill>
+            <a:schemeClr val="accent3"/>
+          </a:solidFill>
+          <a:ln/>
+        </p:spPr>
+        <p:txBody>
+          <a:bodyPr wrap="square" lIns="0" tIns="0" rIns="0" bIns="0" rtlCol="0" anchor="ctr"/>
+          <a:lstStyle/>
+          <a:p>
+            <a:pPr algn="ctr" indent="0" marL="0">
+              <a:buNone/>
+            </a:pPr>
+            <a:r>
+              <a:rPr lang="en-US" sz="1100" b="1" spc="100" kern="0" dirty="0">
+                <a:solidFill>
+                  <a:schemeClr val="bg1"/>
+                </a:solidFill>
+              </a:rPr>
+              <a:t>COUCHE 1</a:t>
+            </a:r>
+            <a:endParaRPr lang="en-US" sz="1100" dirty="0"/>
+          </a:p>
+        </p:txBody>
+      </p:sp>
+      <p:sp>
+        <p:nvSpPr>
+          <p:cNvPr id="8" name="Text 5"/>
+          <p:cNvSpPr txBox="1"/>
+          <p:nvPr/>
+        </p:nvSpPr>
+        <p:spPr>
+          <a:xfrm>
+            <a:off x="2724912" y="1572768"/>
+            <a:ext cx="3099816" cy="1067562"/>
+          </a:xfrm>
+          <a:prstGeom prst="rect">
+            <a:avLst/>
+          </a:prstGeom>
+          <a:noFill/>
+          <a:ln/>
+        </p:spPr>
+        <p:txBody>
+          <a:bodyPr wrap="square" lIns="0" tIns="0" rIns="0" bIns="0" rtlCol="0" anchor="ctr"/>
+          <a:lstStyle/>
+          <a:p>
+            <a:pPr indent="0" marL="0">
+              <a:buNone/>
+            </a:pPr>
+            <a:r>
+              <a:rPr lang="en-US" sz="1800" dirty="0">
+                <a:solidFill>
+                  <a:schemeClr val="tx1"/>
+                </a:solidFill>
+              </a:rPr>
+              <a:t>Bandeau </a:t>
+            </a:r>
+            <a:r>
+              <a:rPr lang="en-US" sz="1800" b="1" dirty="0">
+                <a:solidFill>
+                  <a:schemeClr val="tx1"/>
+                </a:solidFill>
+              </a:rPr>
+              <a:t>vert</a:t>
+            </a:r>
+            <a:r>
+              <a:rPr lang="en-US" sz="1800" dirty="0">
+                <a:solidFill>
+                  <a:schemeClr val="tx1"/>
+                </a:solidFill>
+              </a:rPr>
+              <a:t> : réception intensive. On écoute, on lit, on repère.</a:t>
+            </a:r>
+            <a:endParaRPr lang="en-US" sz="1800" dirty="0"/>
+          </a:p>
+        </p:txBody>
+      </p:sp>
+      <p:sp>
+        <p:nvSpPr>
+          <p:cNvPr id="9" name="Shape 6"/>
+          <p:cNvSpPr/>
+          <p:nvPr/>
+        </p:nvSpPr>
+        <p:spPr>
+          <a:xfrm>
+            <a:off x="548640" y="2750058"/>
+            <a:ext cx="5385816" cy="1104138"/>
+          </a:xfrm>
+          <a:prstGeom prst="roundRect">
+            <a:avLst>
+              <a:gd name="adj" fmla="val 4969"/>
+            </a:avLst>
+          </a:prstGeom>
+          <a:solidFill>
+            <a:schemeClr val="bg1"/>
+          </a:solidFill>
+          <a:ln w="6350">
+            <a:solidFill>
+              <a:srgbClr val="D5DCE6"/>
+            </a:solidFill>
+            <a:prstDash val="solid"/>
+          </a:ln>
+        </p:spPr>
+      </p:sp>
+      <p:sp>
+        <p:nvSpPr>
+          <p:cNvPr id="10" name="Text 7"/>
+          <p:cNvSpPr/>
+          <p:nvPr/>
+        </p:nvSpPr>
+        <p:spPr>
+          <a:xfrm>
+            <a:off x="685800" y="3128391"/>
+            <a:ext cx="1874520" cy="347472"/>
+          </a:xfrm>
+          <a:prstGeom prst="roundRect">
+            <a:avLst>
+              <a:gd name="adj" fmla="val 13158"/>
+            </a:avLst>
+          </a:prstGeom>
+          <a:solidFill>
+            <a:schemeClr val="accent2"/>
+          </a:solidFill>
+          <a:ln/>
+        </p:spPr>
+        <p:txBody>
+          <a:bodyPr wrap="square" lIns="0" tIns="0" rIns="0" bIns="0" rtlCol="0" anchor="ctr"/>
+          <a:lstStyle/>
+          <a:p>
+            <a:pPr algn="ctr" indent="0" marL="0">
+              <a:buNone/>
+            </a:pPr>
+            <a:r>
+              <a:rPr lang="en-US" sz="1100" b="1" spc="100" kern="0" dirty="0">
+                <a:solidFill>
+                  <a:schemeClr val="bg1"/>
+                </a:solidFill>
+              </a:rPr>
+              <a:t>COUCHE 2</a:t>
+            </a:r>
+            <a:endParaRPr lang="en-US" sz="1100" dirty="0"/>
+          </a:p>
+        </p:txBody>
+      </p:sp>
+      <p:sp>
+        <p:nvSpPr>
+          <p:cNvPr id="11" name="Text 8"/>
+          <p:cNvSpPr txBox="1"/>
+          <p:nvPr/>
+        </p:nvSpPr>
+        <p:spPr>
+          <a:xfrm>
+            <a:off x="2724912" y="2768346"/>
+            <a:ext cx="3099816" cy="1067562"/>
+          </a:xfrm>
+          <a:prstGeom prst="rect">
+            <a:avLst/>
+          </a:prstGeom>
+          <a:noFill/>
+          <a:ln/>
+        </p:spPr>
+        <p:txBody>
+          <a:bodyPr wrap="square" lIns="0" tIns="0" rIns="0" bIns="0" rtlCol="0" anchor="ctr"/>
+          <a:lstStyle/>
+          <a:p>
+            <a:pPr indent="0" marL="0">
+              <a:buNone/>
+            </a:pPr>
+            <a:r>
+              <a:rPr lang="en-US" sz="1800" dirty="0">
+                <a:solidFill>
+                  <a:schemeClr val="tx1"/>
+                </a:solidFill>
+              </a:rPr>
+              <a:t>Bandeau </a:t>
+            </a:r>
+            <a:r>
+              <a:rPr lang="en-US" sz="1800" b="1" dirty="0">
+                <a:solidFill>
+                  <a:schemeClr val="tx1"/>
+                </a:solidFill>
+              </a:rPr>
+              <a:t>bleu</a:t>
+            </a:r>
+            <a:r>
+              <a:rPr lang="en-US" sz="1800" dirty="0">
+                <a:solidFill>
+                  <a:schemeClr val="tx1"/>
+                </a:solidFill>
+              </a:rPr>
+              <a:t> : production structurée, avec le zinnenbouwer </a:t>
+            </a:r>
+            <a:r>
+              <a:rPr lang="en-US" sz="1800" b="1" dirty="0">
+                <a:solidFill>
+                  <a:schemeClr val="tx1"/>
+                </a:solidFill>
+              </a:rPr>
+              <a:t>ouvert</a:t>
+            </a:r>
+            <a:r>
+              <a:rPr lang="en-US" sz="1800" dirty="0">
+                <a:solidFill>
+                  <a:schemeClr val="tx1"/>
+                </a:solidFill>
+              </a:rPr>
+              <a:t>.</a:t>
+            </a:r>
+            <a:endParaRPr lang="en-US" sz="1800" dirty="0"/>
+          </a:p>
+        </p:txBody>
+      </p:sp>
+      <p:sp>
+        <p:nvSpPr>
+          <p:cNvPr id="12" name="Shape 9"/>
+          <p:cNvSpPr/>
+          <p:nvPr/>
+        </p:nvSpPr>
+        <p:spPr>
+          <a:xfrm>
+            <a:off x="548640" y="3945636"/>
+            <a:ext cx="5385816" cy="1104138"/>
+          </a:xfrm>
+          <a:prstGeom prst="roundRect">
+            <a:avLst>
+              <a:gd name="adj" fmla="val 4969"/>
+            </a:avLst>
+          </a:prstGeom>
+          <a:solidFill>
+            <a:schemeClr val="bg2"/>
+          </a:solidFill>
+          <a:ln w="6350">
+            <a:solidFill>
+              <a:srgbClr val="D5DCE6"/>
+            </a:solidFill>
+            <a:prstDash val="solid"/>
+          </a:ln>
+        </p:spPr>
+      </p:sp>
+      <p:sp>
+        <p:nvSpPr>
+          <p:cNvPr id="13" name="Text 10"/>
+          <p:cNvSpPr/>
+          <p:nvPr/>
+        </p:nvSpPr>
+        <p:spPr>
+          <a:xfrm>
+            <a:off x="685800" y="4323969"/>
+            <a:ext cx="1874520" cy="347472"/>
+          </a:xfrm>
+          <a:prstGeom prst="roundRect">
+            <a:avLst>
+              <a:gd name="adj" fmla="val 13158"/>
+            </a:avLst>
+          </a:prstGeom>
+          <a:solidFill>
+            <a:schemeClr val="accent1"/>
+          </a:solidFill>
+          <a:ln/>
+        </p:spPr>
+        <p:txBody>
+          <a:bodyPr wrap="square" lIns="0" tIns="0" rIns="0" bIns="0" rtlCol="0" anchor="ctr"/>
+          <a:lstStyle/>
+          <a:p>
+            <a:pPr algn="ctr" indent="0" marL="0">
+              <a:buNone/>
+            </a:pPr>
+            <a:r>
+              <a:rPr lang="en-US" sz="1100" b="1" spc="100" kern="0" dirty="0">
+                <a:solidFill>
+                  <a:schemeClr val="bg1"/>
+                </a:solidFill>
+              </a:rPr>
+              <a:t>COUCHE 3</a:t>
+            </a:r>
+            <a:endParaRPr lang="en-US" sz="1100" dirty="0"/>
+          </a:p>
+        </p:txBody>
+      </p:sp>
+      <p:sp>
+        <p:nvSpPr>
+          <p:cNvPr id="14" name="Text 11"/>
+          <p:cNvSpPr txBox="1"/>
+          <p:nvPr/>
+        </p:nvSpPr>
+        <p:spPr>
+          <a:xfrm>
+            <a:off x="2724912" y="3963924"/>
+            <a:ext cx="3099816" cy="1067562"/>
+          </a:xfrm>
+          <a:prstGeom prst="rect">
+            <a:avLst/>
+          </a:prstGeom>
+          <a:noFill/>
+          <a:ln/>
+        </p:spPr>
+        <p:txBody>
+          <a:bodyPr wrap="square" lIns="0" tIns="0" rIns="0" bIns="0" rtlCol="0" anchor="ctr"/>
+          <a:lstStyle/>
+          <a:p>
+            <a:pPr indent="0" marL="0">
+              <a:buNone/>
+            </a:pPr>
+            <a:r>
+              <a:rPr lang="en-US" sz="1800" dirty="0">
+                <a:solidFill>
+                  <a:schemeClr val="tx1"/>
+                </a:solidFill>
+              </a:rPr>
+              <a:t>Bandeau </a:t>
+            </a:r>
+            <a:r>
+              <a:rPr lang="en-US" sz="1800" b="1" dirty="0">
+                <a:solidFill>
+                  <a:schemeClr val="tx1"/>
+                </a:solidFill>
+              </a:rPr>
+              <a:t>jaune</a:t>
+            </a:r>
+            <a:r>
+              <a:rPr lang="en-US" sz="1800" dirty="0">
+                <a:solidFill>
+                  <a:schemeClr val="tx1"/>
+                </a:solidFill>
+              </a:rPr>
+              <a:t> : fluidité, zinnenbouwer </a:t>
+            </a:r>
+            <a:r>
+              <a:rPr lang="en-US" sz="1800" b="1" dirty="0">
+                <a:solidFill>
+                  <a:schemeClr val="tx1"/>
+                </a:solidFill>
+              </a:rPr>
+              <a:t>fermé</a:t>
+            </a:r>
+            <a:r>
+              <a:rPr lang="en-US" sz="1800" dirty="0">
+                <a:solidFill>
+                  <a:schemeClr val="tx1"/>
+                </a:solidFill>
+              </a:rPr>
+              <a:t>, chronomètre.</a:t>
+            </a:r>
+            <a:endParaRPr lang="en-US" sz="1800" dirty="0"/>
+          </a:p>
+        </p:txBody>
+      </p:sp>
+      <p:sp>
+        <p:nvSpPr>
+          <p:cNvPr id="15" name="Shape 12"/>
+          <p:cNvSpPr/>
+          <p:nvPr/>
+        </p:nvSpPr>
+        <p:spPr>
+          <a:xfrm>
+            <a:off x="548640" y="5141214"/>
+            <a:ext cx="5385816" cy="1104138"/>
+          </a:xfrm>
+          <a:prstGeom prst="roundRect">
+            <a:avLst>
+              <a:gd name="adj" fmla="val 4969"/>
+            </a:avLst>
+          </a:prstGeom>
+          <a:solidFill>
+            <a:schemeClr val="bg1"/>
+          </a:solidFill>
+          <a:ln w="6350">
+            <a:solidFill>
+              <a:srgbClr val="D5DCE6"/>
+            </a:solidFill>
+            <a:prstDash val="solid"/>
+          </a:ln>
+        </p:spPr>
+      </p:sp>
+      <p:sp>
+        <p:nvSpPr>
+          <p:cNvPr id="16" name="Text 13"/>
+          <p:cNvSpPr/>
+          <p:nvPr/>
+        </p:nvSpPr>
+        <p:spPr>
+          <a:xfrm>
+            <a:off x="685800" y="5519547"/>
+            <a:ext cx="1874520" cy="347472"/>
+          </a:xfrm>
+          <a:prstGeom prst="roundRect">
+            <a:avLst>
+              <a:gd name="adj" fmla="val 13158"/>
+            </a:avLst>
+          </a:prstGeom>
+          <a:solidFill>
+            <a:schemeClr val="tx2"/>
+          </a:solidFill>
+          <a:ln/>
+        </p:spPr>
+        <p:txBody>
+          <a:bodyPr wrap="square" lIns="0" tIns="0" rIns="0" bIns="0" rtlCol="0" anchor="ctr"/>
+          <a:lstStyle/>
+          <a:p>
+            <a:pPr algn="ctr" indent="0" marL="0">
+              <a:buNone/>
+            </a:pPr>
+            <a:r>
+              <a:rPr lang="en-US" sz="1100" b="1" spc="100" kern="0" dirty="0">
+                <a:solidFill>
+                  <a:schemeClr val="bg1"/>
+                </a:solidFill>
+              </a:rPr>
+              <a:t>ZINNENBOUWER</a:t>
+            </a:r>
+            <a:endParaRPr lang="en-US" sz="1100" dirty="0"/>
+          </a:p>
+        </p:txBody>
+      </p:sp>
+      <p:sp>
+        <p:nvSpPr>
+          <p:cNvPr id="17" name="Text 14"/>
+          <p:cNvSpPr txBox="1"/>
+          <p:nvPr/>
+        </p:nvSpPr>
+        <p:spPr>
+          <a:xfrm>
+            <a:off x="2724912" y="5159502"/>
+            <a:ext cx="3099816" cy="1067562"/>
+          </a:xfrm>
+          <a:prstGeom prst="rect">
+            <a:avLst/>
+          </a:prstGeom>
+          <a:noFill/>
+          <a:ln/>
+        </p:spPr>
+        <p:txBody>
+          <a:bodyPr wrap="square" lIns="0" tIns="0" rIns="0" bIns="0" rtlCol="0" anchor="ctr"/>
+          <a:lstStyle/>
+          <a:p>
+            <a:pPr indent="0" marL="0">
+              <a:buNone/>
+            </a:pPr>
+            <a:r>
+              <a:rPr lang="en-US" sz="1800" dirty="0">
+                <a:solidFill>
+                  <a:schemeClr val="tx1"/>
+                </a:solidFill>
+              </a:rPr>
+              <a:t>Tableau de </a:t>
+            </a:r>
+            <a:r>
+              <a:rPr lang="en-US" sz="1800" b="1" dirty="0">
+                <a:solidFill>
+                  <a:schemeClr val="tx1"/>
+                </a:solidFill>
+              </a:rPr>
+              <a:t>familles de phrases</a:t>
+            </a:r>
+            <a:r>
+              <a:rPr lang="en-US" sz="1800" dirty="0">
+                <a:solidFill>
+                  <a:schemeClr val="tx1"/>
+                </a:solidFill>
+              </a:rPr>
+              <a:t> : on prend un bloc par colonne.</a:t>
+            </a:r>
+            <a:endParaRPr lang="en-US" sz="1800" dirty="0"/>
+          </a:p>
+        </p:txBody>
+      </p:sp>
+      <p:sp>
+        <p:nvSpPr>
+          <p:cNvPr id="18" name="Shape 15"/>
+          <p:cNvSpPr/>
+          <p:nvPr/>
+        </p:nvSpPr>
+        <p:spPr>
+          <a:xfrm>
+            <a:off x="6254496" y="1554480"/>
+            <a:ext cx="5385816" cy="1104138"/>
+          </a:xfrm>
+          <a:prstGeom prst="roundRect">
+            <a:avLst>
+              <a:gd name="adj" fmla="val 4969"/>
+            </a:avLst>
+          </a:prstGeom>
+          <a:solidFill>
+            <a:schemeClr val="bg2"/>
+          </a:solidFill>
+          <a:ln w="6350">
+            <a:solidFill>
+              <a:srgbClr val="D5DCE6"/>
+            </a:solidFill>
+            <a:prstDash val="solid"/>
+          </a:ln>
+        </p:spPr>
+      </p:sp>
+      <p:sp>
+        <p:nvSpPr>
+          <p:cNvPr id="19" name="Text 16"/>
+          <p:cNvSpPr/>
+          <p:nvPr/>
+        </p:nvSpPr>
+        <p:spPr>
+          <a:xfrm>
+            <a:off x="6391656" y="1932813"/>
+            <a:ext cx="1874520" cy="347472"/>
+          </a:xfrm>
+          <a:prstGeom prst="roundRect">
+            <a:avLst>
+              <a:gd name="adj" fmla="val 13158"/>
+            </a:avLst>
+          </a:prstGeom>
+          <a:solidFill>
+            <a:schemeClr val="accent6"/>
+          </a:solidFill>
+          <a:ln/>
+        </p:spPr>
+        <p:txBody>
+          <a:bodyPr wrap="square" lIns="0" tIns="0" rIns="0" bIns="0" rtlCol="0" anchor="ctr"/>
+          <a:lstStyle/>
+          <a:p>
+            <a:pPr algn="ctr" indent="0" marL="0">
+              <a:buNone/>
+            </a:pPr>
+            <a:r>
+              <a:rPr lang="en-US" sz="1100" b="1" spc="100" kern="0" dirty="0">
+                <a:solidFill>
+                  <a:schemeClr val="bg1"/>
+                </a:solidFill>
+              </a:rPr>
+              <a:t>EXTRA</a:t>
+            </a:r>
+            <a:endParaRPr lang="en-US" sz="1100" dirty="0"/>
+          </a:p>
+        </p:txBody>
+      </p:sp>
+      <p:sp>
+        <p:nvSpPr>
+          <p:cNvPr id="20" name="Text 17"/>
+          <p:cNvSpPr txBox="1"/>
+          <p:nvPr/>
+        </p:nvSpPr>
+        <p:spPr>
+          <a:xfrm>
+            <a:off x="8430768" y="1572768"/>
+            <a:ext cx="3099816" cy="1067562"/>
+          </a:xfrm>
+          <a:prstGeom prst="rect">
+            <a:avLst/>
+          </a:prstGeom>
+          <a:noFill/>
+          <a:ln/>
+        </p:spPr>
+        <p:txBody>
+          <a:bodyPr wrap="square" lIns="0" tIns="0" rIns="0" bIns="0" rtlCol="0" anchor="ctr"/>
+          <a:lstStyle/>
+          <a:p>
+            <a:pPr indent="0" marL="0">
+              <a:buNone/>
+            </a:pPr>
+            <a:r>
+              <a:rPr lang="en-US" sz="1800" dirty="0">
+                <a:solidFill>
+                  <a:schemeClr val="tx1"/>
+                </a:solidFill>
+              </a:rPr>
+              <a:t>Exercice </a:t>
+            </a:r>
+            <a:r>
+              <a:rPr lang="en-US" sz="1800" b="1" dirty="0">
+                <a:solidFill>
+                  <a:schemeClr val="tx1"/>
+                </a:solidFill>
+              </a:rPr>
+              <a:t>supplémentaire</a:t>
+            </a:r>
+            <a:r>
+              <a:rPr lang="en-US" sz="1800" dirty="0">
+                <a:solidFill>
+                  <a:schemeClr val="tx1"/>
+                </a:solidFill>
+              </a:rPr>
+              <a:t> (mots composés, pronoms…).</a:t>
+            </a:r>
+            <a:endParaRPr lang="en-US" sz="1800" dirty="0"/>
+          </a:p>
+        </p:txBody>
+      </p:sp>
+      <p:sp>
+        <p:nvSpPr>
+          <p:cNvPr id="21" name="Shape 18"/>
+          <p:cNvSpPr/>
+          <p:nvPr/>
+        </p:nvSpPr>
+        <p:spPr>
+          <a:xfrm>
+            <a:off x="6254496" y="2750058"/>
+            <a:ext cx="5385816" cy="1104138"/>
+          </a:xfrm>
+          <a:prstGeom prst="roundRect">
+            <a:avLst>
+              <a:gd name="adj" fmla="val 4969"/>
+            </a:avLst>
+          </a:prstGeom>
+          <a:solidFill>
+            <a:schemeClr val="bg1"/>
+          </a:solidFill>
+          <a:ln w="6350">
+            <a:solidFill>
+              <a:srgbClr val="D5DCE6"/>
+            </a:solidFill>
+            <a:prstDash val="solid"/>
+          </a:ln>
+        </p:spPr>
+      </p:sp>
+      <p:sp>
+        <p:nvSpPr>
+          <p:cNvPr id="22" name="Text 19"/>
+          <p:cNvSpPr/>
+          <p:nvPr/>
+        </p:nvSpPr>
+        <p:spPr>
+          <a:xfrm>
+            <a:off x="6391656" y="3128391"/>
+            <a:ext cx="1874520" cy="347472"/>
+          </a:xfrm>
+          <a:prstGeom prst="roundRect">
+            <a:avLst>
+              <a:gd name="adj" fmla="val 13158"/>
+            </a:avLst>
+          </a:prstGeom>
+          <a:solidFill>
+            <a:schemeClr val="accent1"/>
+          </a:solidFill>
+          <a:ln/>
+        </p:spPr>
+        <p:txBody>
+          <a:bodyPr wrap="square" lIns="0" tIns="0" rIns="0" bIns="0" rtlCol="0" anchor="ctr"/>
+          <a:lstStyle/>
+          <a:p>
+            <a:pPr algn="ctr" indent="0" marL="0">
+              <a:buNone/>
+            </a:pPr>
+            <a:r>
+              <a:rPr lang="en-US" sz="1100" b="1" spc="100" kern="0" dirty="0">
+                <a:solidFill>
+                  <a:schemeClr val="bg1"/>
+                </a:solidFill>
+              </a:rPr>
+              <a:t>JIJ NU!</a:t>
+            </a:r>
+            <a:endParaRPr lang="en-US" sz="1100" dirty="0"/>
+          </a:p>
+        </p:txBody>
+      </p:sp>
+      <p:sp>
+        <p:nvSpPr>
+          <p:cNvPr id="23" name="Text 20"/>
+          <p:cNvSpPr txBox="1"/>
+          <p:nvPr/>
+        </p:nvSpPr>
+        <p:spPr>
+          <a:xfrm>
+            <a:off x="8430768" y="2768346"/>
+            <a:ext cx="3099816" cy="1067562"/>
+          </a:xfrm>
+          <a:prstGeom prst="rect">
+            <a:avLst/>
+          </a:prstGeom>
+          <a:noFill/>
+          <a:ln/>
+        </p:spPr>
+        <p:txBody>
+          <a:bodyPr wrap="square" lIns="0" tIns="0" rIns="0" bIns="0" rtlCol="0" anchor="ctr"/>
+          <a:lstStyle/>
+          <a:p>
+            <a:pPr indent="0" marL="0">
+              <a:buNone/>
+            </a:pPr>
+            <a:r>
+              <a:rPr lang="en-US" sz="1800" dirty="0">
+                <a:solidFill>
+                  <a:schemeClr val="tx1"/>
+                </a:solidFill>
+              </a:rPr>
+              <a:t>« </a:t>
+            </a:r>
+            <a:r>
+              <a:rPr lang="en-US" sz="1800" b="1" dirty="0">
+                <a:solidFill>
+                  <a:schemeClr val="tx1"/>
+                </a:solidFill>
+              </a:rPr>
+              <a:t>À toi !</a:t>
+            </a:r>
+            <a:r>
+              <a:rPr lang="en-US" sz="1800" dirty="0">
+                <a:solidFill>
+                  <a:schemeClr val="tx1"/>
+                </a:solidFill>
+              </a:rPr>
+              <a:t> » : mise en situation orale en fin de séquence.</a:t>
+            </a:r>
+            <a:endParaRPr lang="en-US" sz="1800" dirty="0"/>
+          </a:p>
+        </p:txBody>
+      </p:sp>
+      <p:sp>
+        <p:nvSpPr>
+          <p:cNvPr id="24" name="Shape 21"/>
+          <p:cNvSpPr/>
+          <p:nvPr/>
+        </p:nvSpPr>
+        <p:spPr>
+          <a:xfrm>
+            <a:off x="6254496" y="3945636"/>
+            <a:ext cx="5385816" cy="1104138"/>
+          </a:xfrm>
+          <a:prstGeom prst="roundRect">
+            <a:avLst>
+              <a:gd name="adj" fmla="val 4969"/>
+            </a:avLst>
+          </a:prstGeom>
+          <a:solidFill>
+            <a:schemeClr val="bg2"/>
+          </a:solidFill>
+          <a:ln w="6350">
+            <a:solidFill>
+              <a:srgbClr val="D5DCE6"/>
+            </a:solidFill>
+            <a:prstDash val="solid"/>
+          </a:ln>
+        </p:spPr>
+      </p:sp>
+      <p:sp>
+        <p:nvSpPr>
+          <p:cNvPr id="25" name="Text 22"/>
+          <p:cNvSpPr/>
+          <p:nvPr/>
+        </p:nvSpPr>
+        <p:spPr>
+          <a:xfrm>
+            <a:off x="6391656" y="4323969"/>
+            <a:ext cx="1874520" cy="347472"/>
+          </a:xfrm>
+          <a:prstGeom prst="roundRect">
+            <a:avLst>
+              <a:gd name="adj" fmla="val 13158"/>
+            </a:avLst>
+          </a:prstGeom>
+          <a:solidFill>
+            <a:schemeClr val="accent4"/>
+          </a:solidFill>
+          <a:ln/>
+        </p:spPr>
+        <p:txBody>
+          <a:bodyPr wrap="square" lIns="0" tIns="0" rIns="0" bIns="0" rtlCol="0" anchor="ctr"/>
+          <a:lstStyle/>
+          <a:p>
+            <a:pPr algn="ctr" indent="0" marL="0">
+              <a:buNone/>
+            </a:pPr>
+            <a:r>
+              <a:rPr lang="en-US" sz="1100" b="1" spc="100" kern="0" dirty="0">
+                <a:solidFill>
+                  <a:schemeClr val="bg1"/>
+                </a:solidFill>
+              </a:rPr>
+              <a:t>KLANKMOMENT</a:t>
+            </a:r>
+            <a:endParaRPr lang="en-US" sz="1100" dirty="0"/>
+          </a:p>
+        </p:txBody>
+      </p:sp>
+      <p:sp>
+        <p:nvSpPr>
+          <p:cNvPr id="26" name="Text 23"/>
+          <p:cNvSpPr txBox="1"/>
+          <p:nvPr/>
+        </p:nvSpPr>
+        <p:spPr>
+          <a:xfrm>
+            <a:off x="8430768" y="3963924"/>
+            <a:ext cx="3099816" cy="1067562"/>
+          </a:xfrm>
+          <a:prstGeom prst="rect">
+            <a:avLst/>
+          </a:prstGeom>
+          <a:noFill/>
+          <a:ln/>
+        </p:spPr>
+        <p:txBody>
+          <a:bodyPr wrap="square" lIns="0" tIns="0" rIns="0" bIns="0" rtlCol="0" anchor="ctr"/>
+          <a:lstStyle/>
+          <a:p>
+            <a:pPr indent="0" marL="0">
+              <a:buNone/>
+            </a:pPr>
+            <a:r>
+              <a:rPr lang="en-US" sz="1800" dirty="0">
+                <a:solidFill>
+                  <a:schemeClr val="tx1"/>
+                </a:solidFill>
+              </a:rPr>
+              <a:t>Moment de </a:t>
+            </a:r>
+            <a:r>
+              <a:rPr lang="en-US" sz="1800" b="1" dirty="0">
+                <a:solidFill>
+                  <a:schemeClr val="tx1"/>
+                </a:solidFill>
+              </a:rPr>
+              <a:t>prononciation</a:t>
+            </a:r>
+            <a:r>
+              <a:rPr lang="en-US" sz="1800" dirty="0">
+                <a:solidFill>
+                  <a:schemeClr val="tx1"/>
+                </a:solidFill>
+              </a:rPr>
+              <a:t> (g, ch, ’s…).</a:t>
+            </a:r>
+            <a:endParaRPr lang="en-US" sz="1800" dirty="0"/>
+          </a:p>
+        </p:txBody>
+      </p:sp>
+      <p:sp>
+        <p:nvSpPr>
+          <p:cNvPr id="27" name="Shape 24"/>
+          <p:cNvSpPr/>
+          <p:nvPr/>
+        </p:nvSpPr>
+        <p:spPr>
+          <a:xfrm>
+            <a:off x="6254496" y="5141214"/>
+            <a:ext cx="5385816" cy="1104138"/>
+          </a:xfrm>
+          <a:prstGeom prst="roundRect">
+            <a:avLst>
+              <a:gd name="adj" fmla="val 4969"/>
+            </a:avLst>
+          </a:prstGeom>
+          <a:solidFill>
+            <a:schemeClr val="bg1"/>
+          </a:solidFill>
+          <a:ln w="6350">
+            <a:solidFill>
+              <a:srgbClr val="D5DCE6"/>
+            </a:solidFill>
+            <a:prstDash val="solid"/>
+          </a:ln>
+        </p:spPr>
+      </p:sp>
+      <p:sp>
+        <p:nvSpPr>
+          <p:cNvPr id="28" name="Text 25"/>
+          <p:cNvSpPr/>
+          <p:nvPr/>
+        </p:nvSpPr>
+        <p:spPr>
+          <a:xfrm>
+            <a:off x="6391656" y="5519547"/>
+            <a:ext cx="1874520" cy="347472"/>
+          </a:xfrm>
+          <a:prstGeom prst="roundRect">
+            <a:avLst>
+              <a:gd name="adj" fmla="val 13158"/>
+            </a:avLst>
+          </a:prstGeom>
+          <a:solidFill>
+            <a:schemeClr val="tx2"/>
+          </a:solidFill>
+          <a:ln/>
+        </p:spPr>
+        <p:txBody>
+          <a:bodyPr wrap="square" lIns="0" tIns="0" rIns="0" bIns="0" rtlCol="0" anchor="ctr"/>
+          <a:lstStyle/>
+          <a:p>
+            <a:pPr algn="ctr" indent="0" marL="0">
+              <a:buNone/>
+            </a:pPr>
+            <a:r>
+              <a:rPr lang="en-US" sz="1100" b="1" spc="100" kern="0" dirty="0">
+                <a:solidFill>
+                  <a:schemeClr val="bg1"/>
+                </a:solidFill>
+              </a:rPr>
+              <a:t>+ BONUS</a:t>
+            </a:r>
+            <a:endParaRPr lang="en-US" sz="1100" dirty="0"/>
+          </a:p>
+        </p:txBody>
+      </p:sp>
+      <p:sp>
+        <p:nvSpPr>
+          <p:cNvPr id="29" name="Text 26"/>
+          <p:cNvSpPr txBox="1"/>
+          <p:nvPr/>
+        </p:nvSpPr>
+        <p:spPr>
+          <a:xfrm>
+            <a:off x="8430768" y="5159502"/>
+            <a:ext cx="3099816" cy="1067562"/>
+          </a:xfrm>
+          <a:prstGeom prst="rect">
+            <a:avLst/>
+          </a:prstGeom>
+          <a:noFill/>
+          <a:ln/>
+        </p:spPr>
+        <p:txBody>
+          <a:bodyPr wrap="square" lIns="0" tIns="0" rIns="0" bIns="0" rtlCol="0" anchor="ctr"/>
+          <a:lstStyle/>
+          <a:p>
+            <a:pPr indent="0" marL="0">
+              <a:buNone/>
+            </a:pPr>
+            <a:r>
+              <a:rPr lang="en-US" sz="1800" dirty="0">
+                <a:solidFill>
+                  <a:schemeClr val="tx1"/>
+                </a:solidFill>
+              </a:rPr>
+              <a:t>Exercice </a:t>
+            </a:r>
+            <a:r>
+              <a:rPr lang="en-US" sz="1800" b="1" dirty="0">
+                <a:solidFill>
+                  <a:schemeClr val="tx1"/>
+                </a:solidFill>
+              </a:rPr>
+              <a:t>ajouté</a:t>
+            </a:r>
+            <a:r>
+              <a:rPr lang="en-US" sz="1800" dirty="0">
+                <a:solidFill>
+                  <a:schemeClr val="tx1"/>
+                </a:solidFill>
+              </a:rPr>
+              <a:t> par le professeur, hors syllabus.</a:t>
+            </a:r>
+            <a:endParaRPr lang="en-US" sz="1800" dirty="0"/>
+          </a:p>
+        </p:txBody>
+      </p:sp>
+      <p:sp>
+        <p:nvSpPr>
+          <p:cNvPr id="25" name="Slide Number Placeholder 0"/>
+          <p:cNvSpPr>
+            <a:spLocks noGrp="1"/>
+          </p:cNvSpPr>
+          <p:nvPr>
+            <p:ph type="sldNum" sz="quarter" idx="4294967295"/>
+          </p:nvPr>
+        </p:nvSpPr>
+        <p:spPr>
+          <a:xfrm>
+            <a:off x="11091672" y="6446520"/>
+            <a:ext cx="548640" cy="274320"/>
+          </a:xfrm>
+          <a:prstGeom prst="rect">
+            <a:avLst/>
+          </a:prstGeom>
+          <a:extLst>
+            <a:ext uri="{C572A759-6A51-4108-AA02-DFA0A04FC94B}">
+              <ma14:wrappingTextBoxFlag xmlns:ma14="http://schemas.microsoft.com/office/mac/drawingml/2011/main" val="0"/>
+            </a:ext>
+          </a:extLst>
+        </p:spPr>
+        <p:txBody>
+          <a:bodyPr/>
+          <a:lstStyle>
+            <a:lvl1pPr>
+              <a:defRPr sz="1000">
+                <a:solidFill>
+                  <a:srgbClr val="4A5A70"/>
+                </a:solidFill>
+              </a:defRPr>
+            </a:lvl1pPr>
+          </a:lstStyle>
+          <a:p>
+            <a:pPr algn="r"/>
+            <a:fld id="{F7021451-1387-4CA6-816F-3879F97B5CBC}" type="slidenum">
+              <a:rPr b="0" lang="en-US"/>
               <a:t>5</a:t>
             </a:fld>
             <a:endParaRPr lang="en-US"/>
@@ -29439,7 +29497,7 @@
                   <a:schemeClr val="tx2"/>
                 </a:solidFill>
               </a:rPr>
-              <a:t>Wie is wie? Les personnages</a:t>
+              <a:t>Premiers pas : Emma &amp; Pieter</a:t>
             </a:r>
             <a:endParaRPr lang="en-US" sz="3200" dirty="0"/>
           </a:p>
@@ -29515,7 +29573,7 @@
                   <a:schemeClr val="accent5"/>
                 </a:solidFill>
               </a:rPr>
-              <a:t>Livret p. 2</a:t>
+              <a:t>Livret p. 1</a:t>
             </a:r>
             <a:endParaRPr lang="en-US" sz="1200" dirty="0"/>
           </a:p>
@@ -29537,8 +29595,8 @@
         </p:blipFill>
         <p:spPr>
           <a:xfrm>
-            <a:off x="548640" y="1481328"/>
-            <a:ext cx="4809744" cy="4809744"/>
+            <a:off x="548640" y="1508760"/>
+            <a:ext cx="6035040" cy="4029521"/>
           </a:xfrm>
           <a:prstGeom prst="rect">
             <a:avLst/>
@@ -29554,69 +29612,264 @@
       </p:pic>
       <p:sp>
         <p:nvSpPr>
-          <p:cNvPr id="7" name="aside"/>
+          <p:cNvPr id="7" name="Text 3"/>
+          <p:cNvSpPr txBox="1"/>
+          <p:nvPr/>
+        </p:nvSpPr>
+        <p:spPr>
+          <a:xfrm>
+            <a:off x="6995160" y="1508760"/>
+            <a:ext cx="4645152" cy="3432048"/>
+          </a:xfrm>
+          <a:prstGeom prst="rect">
+            <a:avLst/>
+          </a:prstGeom>
+          <a:noFill/>
+          <a:ln/>
+        </p:spPr>
+        <p:txBody>
+          <a:bodyPr wrap="square" lIns="0" tIns="0" rIns="0" bIns="0" rtlCol="0" anchor="t"/>
+          <a:lstStyle/>
+          <a:p>
+            <a:pPr indent="0" marL="0">
+              <a:spcAft>
+                <a:spcPts val="1000"/>
+              </a:spcAft>
+              <a:buNone/>
+            </a:pPr>
+            <a:r>
+              <a:rPr lang="en-US" sz="2000" dirty="0">
+                <a:solidFill>
+                  <a:schemeClr val="tx1"/>
+                </a:solidFill>
+              </a:rPr>
+              <a:t>Ce dialogue est votre porte d’entrée : il contient les </a:t>
+            </a:r>
+            <a:r>
+              <a:rPr lang="en-US" sz="2000" b="1" dirty="0">
+                <a:solidFill>
+                  <a:schemeClr val="tx1"/>
+                </a:solidFill>
+              </a:rPr>
+              <a:t>quatre piliers</a:t>
+            </a:r>
+            <a:r>
+              <a:rPr lang="en-US" sz="2000" dirty="0">
+                <a:solidFill>
+                  <a:schemeClr val="tx1"/>
+                </a:solidFill>
+              </a:rPr>
+              <a:t> de toute interaction sociale.</a:t>
+            </a:r>
+            <a:endParaRPr lang="en-US" sz="2000" dirty="0"/>
+          </a:p>
+          <a:p>
+            <a:pPr indent="0" marL="0">
+              <a:spcAft>
+                <a:spcPts val="1000"/>
+              </a:spcAft>
+              <a:buNone/>
+            </a:pPr>
+            <a:r>
+              <a:rPr lang="en-US" sz="2000" b="1" dirty="0">
+                <a:solidFill>
+                  <a:schemeClr val="tx1"/>
+                </a:solidFill>
+              </a:rPr>
+              <a:t>1</a:t>
+            </a:r>
+            <a:r>
+              <a:rPr lang="en-US" sz="2000" dirty="0">
+                <a:solidFill>
+                  <a:schemeClr val="tx1"/>
+                </a:solidFill>
+              </a:rPr>
+              <a:t> Saluer · </a:t>
+            </a:r>
+            <a:r>
+              <a:rPr lang="en-US" sz="2000" b="1" dirty="0">
+                <a:solidFill>
+                  <a:schemeClr val="tx1"/>
+                </a:solidFill>
+              </a:rPr>
+              <a:t>2</a:t>
+            </a:r>
+            <a:r>
+              <a:rPr lang="en-US" sz="2000" dirty="0">
+                <a:solidFill>
+                  <a:schemeClr val="tx1"/>
+                </a:solidFill>
+              </a:rPr>
+              <a:t> Prendre des nouvelles · </a:t>
+            </a:r>
+            <a:r>
+              <a:rPr lang="en-US" sz="2000" b="1" dirty="0">
+                <a:solidFill>
+                  <a:schemeClr val="tx1"/>
+                </a:solidFill>
+              </a:rPr>
+              <a:t>3</a:t>
+            </a:r>
+            <a:r>
+              <a:rPr lang="en-US" sz="2000" dirty="0">
+                <a:solidFill>
+                  <a:schemeClr val="tx1"/>
+                </a:solidFill>
+              </a:rPr>
+              <a:t> Être et avoir (</a:t>
+            </a:r>
+            <a:r>
+              <a:rPr lang="en-US" sz="2000" b="1" dirty="0">
+                <a:solidFill>
+                  <a:schemeClr val="tx1"/>
+                </a:solidFill>
+              </a:rPr>
+              <a:t>zijn</a:t>
+            </a:r>
+            <a:r>
+              <a:rPr lang="en-US" sz="2000" dirty="0">
+                <a:solidFill>
+                  <a:schemeClr val="tx1"/>
+                </a:solidFill>
+              </a:rPr>
+              <a:t> &amp; </a:t>
+            </a:r>
+            <a:r>
+              <a:rPr lang="en-US" sz="2000" b="1" dirty="0">
+                <a:solidFill>
+                  <a:schemeClr val="tx1"/>
+                </a:solidFill>
+              </a:rPr>
+              <a:t>hebben</a:t>
+            </a:r>
+            <a:r>
+              <a:rPr lang="en-US" sz="2000" dirty="0">
+                <a:solidFill>
+                  <a:schemeClr val="tx1"/>
+                </a:solidFill>
+              </a:rPr>
+              <a:t>) · </a:t>
+            </a:r>
+            <a:r>
+              <a:rPr lang="en-US" sz="2000" b="1" dirty="0">
+                <a:solidFill>
+                  <a:schemeClr val="tx1"/>
+                </a:solidFill>
+              </a:rPr>
+              <a:t>4</a:t>
+            </a:r>
+            <a:r>
+              <a:rPr lang="en-US" sz="2000" dirty="0">
+                <a:solidFill>
+                  <a:schemeClr val="tx1"/>
+                </a:solidFill>
+              </a:rPr>
+              <a:t> Prendre congé.</a:t>
+            </a:r>
+            <a:endParaRPr lang="en-US" sz="2000" dirty="0"/>
+          </a:p>
+          <a:p>
+            <a:pPr indent="0" marL="0">
+              <a:spcAft>
+                <a:spcPts val="1000"/>
+              </a:spcAft>
+              <a:buNone/>
+            </a:pPr>
+            <a:r>
+              <a:rPr lang="en-US" sz="2000" b="1" dirty="0">
+                <a:solidFill>
+                  <a:schemeClr val="tx1"/>
+                </a:solidFill>
+              </a:rPr>
+              <a:t>Quatre séquences</a:t>
+            </a:r>
+            <a:r>
+              <a:rPr lang="en-US" sz="2000" dirty="0">
+                <a:solidFill>
+                  <a:schemeClr val="tx1"/>
+                </a:solidFill>
+              </a:rPr>
+              <a:t> : chacune = un extrait du dialogue + une règle ciblée + un exercice immédiat.</a:t>
+            </a:r>
+            <a:endParaRPr lang="en-US" sz="2000" dirty="0"/>
+          </a:p>
+        </p:txBody>
+      </p:sp>
+      <p:sp>
+        <p:nvSpPr>
+          <p:cNvPr id="8" name="Shape 4"/>
           <p:cNvSpPr/>
           <p:nvPr/>
         </p:nvSpPr>
         <p:spPr>
           <a:xfrm>
-            <a:off x="5678424" y="1481328"/>
-            <a:ext cx="5961888" cy="4809744"/>
+            <a:off x="6995160" y="5123688"/>
+            <a:ext cx="4645152" cy="1167384"/>
           </a:xfrm>
           <a:prstGeom prst="roundRect">
             <a:avLst>
-              <a:gd name="adj" fmla="val 1521"/>
+              <a:gd name="adj" fmla="val 6266"/>
             </a:avLst>
           </a:prstGeom>
           <a:solidFill>
             <a:schemeClr val="accent1">
-              <a:alpha val="10000"/>
+              <a:alpha val="12000"/>
             </a:schemeClr>
           </a:solidFill>
           <a:ln w="12700">
             <a:solidFill>
-              <a:schemeClr val="accent1">
-                <a:alpha val="60000"/>
-              </a:schemeClr>
+              <a:srgbClr val="D9700F"/>
             </a:solidFill>
             <a:prstDash val="solid"/>
           </a:ln>
         </p:spPr>
       </p:sp>
-      <p:pic>
-        <p:nvPicPr>
-          <p:cNvPr id="8" name="Image 1" descr="preencoded.png">    </p:cNvPr>
-          <p:cNvPicPr>
-            <a:picLocks noChangeAspect="1"/>
-          </p:cNvPicPr>
-          <p:nvPr/>
-        </p:nvPicPr>
-        <p:blipFill>
-          <a:blip r:embed="rId2"/>
-          <a:stretch>
-            <a:fillRect/>
-          </a:stretch>
-        </p:blipFill>
-        <p:spPr>
-          <a:xfrm>
-            <a:off x="5861304" y="1664208"/>
-            <a:ext cx="292608" cy="292608"/>
+      <p:sp>
+        <p:nvSpPr>
+          <p:cNvPr id="9" name="Text 5"/>
+          <p:cNvSpPr txBox="1"/>
+          <p:nvPr/>
+        </p:nvSpPr>
+        <p:spPr>
+          <a:xfrm>
+            <a:off x="7178040" y="5215128"/>
+            <a:ext cx="4279392" cy="292608"/>
           </a:xfrm>
           <a:prstGeom prst="rect">
             <a:avLst/>
           </a:prstGeom>
-        </p:spPr>
-      </p:pic>
-      <p:sp>
-        <p:nvSpPr>
-          <p:cNvPr id="9" name="Text 4"/>
+          <a:noFill/>
+          <a:ln/>
+        </p:spPr>
+        <p:txBody>
+          <a:bodyPr wrap="square" lIns="0" tIns="0" rIns="0" bIns="0" rtlCol="0" anchor="ctr"/>
+          <a:lstStyle/>
+          <a:p>
+            <a:pPr indent="0" marL="0">
+              <a:buNone/>
+            </a:pPr>
+            <a:r>
+              <a:rPr lang="en-US" sz="1200" b="1" spc="100" kern="0" dirty="0">
+                <a:solidFill>
+                  <a:schemeClr val="accent1"/>
+                </a:solidFill>
+              </a:rPr>
+              <a:t>QUESTION À LA CLASSE</a:t>
+            </a:r>
+            <a:endParaRPr lang="en-US" sz="1200" dirty="0"/>
+          </a:p>
+        </p:txBody>
+      </p:sp>
+      <p:sp>
+        <p:nvSpPr>
+          <p:cNvPr id="10" name="Text 6"/>
           <p:cNvSpPr txBox="1"/>
           <p:nvPr/>
         </p:nvSpPr>
         <p:spPr>
           <a:xfrm>
-            <a:off x="6245352" y="1636776"/>
-            <a:ext cx="5230368" cy="347472"/>
+            <a:off x="7178040" y="5507736"/>
+            <a:ext cx="4279392" cy="710184"/>
           </a:xfrm>
           <a:prstGeom prst="rect">
             <a:avLst/>
@@ -29625,163 +29878,21 @@
           <a:ln/>
         </p:spPr>
         <p:txBody>
-          <a:bodyPr wrap="square" lIns="0" tIns="0" rIns="0" bIns="0" rtlCol="0" anchor="ctr"/>
+          <a:bodyPr wrap="square" lIns="0" tIns="0" rIns="0" bIns="0" rtlCol="0" anchor="t"/>
           <a:lstStyle/>
           <a:p>
             <a:pPr indent="0" marL="0">
               <a:buNone/>
             </a:pPr>
             <a:r>
-              <a:rPr lang="en-US" sz="1400" b="1" spc="100" kern="0" dirty="0">
-                <a:solidFill>
-                  <a:schemeClr val="accent1"/>
-                </a:solidFill>
-              </a:rPr>
-              <a:t>EMMA &amp; PIETER : UN TANDEM</a:t>
-            </a:r>
-            <a:endParaRPr lang="en-US" sz="1400" dirty="0"/>
-          </a:p>
-        </p:txBody>
-      </p:sp>
-      <p:sp>
-        <p:nvSpPr>
-          <p:cNvPr id="10" name="Text 5"/>
-          <p:cNvSpPr txBox="1"/>
-          <p:nvPr/>
-        </p:nvSpPr>
-        <p:spPr>
-          <a:xfrm>
-            <a:off x="5843016" y="2075688"/>
-            <a:ext cx="5632704" cy="4078224"/>
-          </a:xfrm>
-          <a:prstGeom prst="rect">
-            <a:avLst/>
-          </a:prstGeom>
-          <a:noFill/>
-          <a:ln/>
-        </p:spPr>
-        <p:txBody>
-          <a:bodyPr wrap="square" lIns="0" tIns="0" rIns="0" bIns="0" rtlCol="0" anchor="t"/>
-          <a:lstStyle/>
-          <a:p>
-            <a:pPr marL="177800" indent="-177800">
-              <a:spcAft>
-                <a:spcPts val="600"/>
-              </a:spcAft>
-              <a:buSzPct val="100000"/>
-              <a:buChar char="•"/>
-            </a:pPr>
-            <a:r>
-              <a:rPr lang="en-US" sz="1800" b="1" dirty="0">
+              <a:rPr lang="en-US" sz="1700" dirty="0">
                 <a:solidFill>
                   <a:schemeClr val="tx1"/>
                 </a:solidFill>
               </a:rPr>
-              <a:t>Emma</a:t>
-            </a:r>
-            <a:r>
-              <a:rPr lang="en-US" sz="1800" dirty="0">
-                <a:solidFill>
-                  <a:schemeClr val="tx1"/>
-                </a:solidFill>
-              </a:rPr>
-              <a:t> : Bergen, studente, ze leert Nederlands, ze heeft een broer.</a:t>
-            </a:r>
-            <a:endParaRPr lang="en-US" sz="1800" dirty="0"/>
-          </a:p>
-          <a:p>
-            <a:pPr marL="177800" indent="-177800">
-              <a:spcAft>
-                <a:spcPts val="600"/>
-              </a:spcAft>
-              <a:buSzPct val="100000"/>
-              <a:buChar char="•"/>
-            </a:pPr>
-            <a:r>
-              <a:rPr lang="en-US" sz="1800" b="1" dirty="0">
-                <a:solidFill>
-                  <a:schemeClr val="tx1"/>
-                </a:solidFill>
-              </a:rPr>
-              <a:t>Pieter</a:t>
-            </a:r>
-            <a:r>
-              <a:rPr lang="en-US" sz="1800" dirty="0">
-                <a:solidFill>
-                  <a:schemeClr val="tx1"/>
-                </a:solidFill>
-              </a:rPr>
-              <a:t> : Nederland, stagiair op een school in België, hij heeft een zus.</a:t>
-            </a:r>
-            <a:endParaRPr lang="en-US" sz="1800" dirty="0"/>
-          </a:p>
-          <a:p>
-            <a:pPr marL="177800" indent="-177800">
-              <a:spcAft>
-                <a:spcPts val="600"/>
-              </a:spcAft>
-              <a:buSzPct val="100000"/>
-              <a:buChar char="•"/>
-            </a:pPr>
-            <a:r>
-              <a:rPr lang="en-US" sz="1800" b="1" dirty="0">
-                <a:solidFill>
-                  <a:schemeClr val="tx1"/>
-                </a:solidFill>
-              </a:rPr>
-              <a:t>Sarah</a:t>
-            </a:r>
-            <a:r>
-              <a:rPr lang="en-US" sz="1800" dirty="0">
-                <a:solidFill>
-                  <a:schemeClr val="tx1"/>
-                </a:solidFill>
-              </a:rPr>
-              <a:t> : Gent, collega van Pieter, ze heeft kinderen.</a:t>
-            </a:r>
-            <a:endParaRPr lang="en-US" sz="1800" dirty="0"/>
-          </a:p>
-          <a:p>
-            <a:pPr marL="177800" indent="-177800">
-              <a:spcAft>
-                <a:spcPts val="600"/>
-              </a:spcAft>
-              <a:buSzPct val="100000"/>
-              <a:buChar char="•"/>
-            </a:pPr>
-            <a:r>
-              <a:rPr lang="en-US" sz="1800" b="1" dirty="0">
-                <a:solidFill>
-                  <a:schemeClr val="tx1"/>
-                </a:solidFill>
-              </a:rPr>
-              <a:t>Meneer Janssens</a:t>
-            </a:r>
-            <a:r>
-              <a:rPr lang="en-US" sz="1800" dirty="0">
-                <a:solidFill>
-                  <a:schemeClr val="tx1"/>
-                </a:solidFill>
-              </a:rPr>
-              <a:t> : stagebegeleider van Pieter — Pieter zegt </a:t>
-            </a:r>
-            <a:r>
-              <a:rPr lang="en-US" sz="1800" b="1" dirty="0">
-                <a:solidFill>
-                  <a:schemeClr val="tx1"/>
-                </a:solidFill>
-              </a:rPr>
-              <a:t>u</a:t>
-            </a:r>
-            <a:r>
-              <a:rPr lang="en-US" sz="1800" dirty="0">
-                <a:solidFill>
-                  <a:schemeClr val="tx1"/>
-                </a:solidFill>
-              </a:rPr>
-              <a:t> tegen hem.</a:t>
-            </a:r>
-            <a:endParaRPr lang="en-US" sz="1800" dirty="0"/>
+              <a:t>Regardez l’image : qui sont-ils, où sont-ils, que se disent-ils ?</a:t>
+            </a:r>
+            <a:endParaRPr lang="en-US" sz="1700" dirty="0"/>
           </a:p>
         </p:txBody>
       </p:sp>
@@ -29887,7 +29998,7 @@
                   <a:schemeClr val="tx2"/>
                 </a:solidFill>
               </a:rPr>
-              <a:t>Premiers pas : Emma &amp; Pieter</a:t>
+              <a:t>Wie is wie? Les personnages</a:t>
             </a:r>
             <a:endParaRPr lang="en-US" sz="3200" dirty="0"/>
           </a:p>
@@ -29963,7 +30074,7 @@
                   <a:schemeClr val="accent5"/>
                 </a:solidFill>
               </a:rPr>
-              <a:t>Livret p. 1</a:t>
+              <a:t>Livret p. 2</a:t>
             </a:r>
             <a:endParaRPr lang="en-US" sz="1200" dirty="0"/>
           </a:p>
@@ -29985,8 +30096,8 @@
         </p:blipFill>
         <p:spPr>
           <a:xfrm>
-            <a:off x="548640" y="1508760"/>
-            <a:ext cx="6035040" cy="4029521"/>
+            <a:off x="548640" y="1481328"/>
+            <a:ext cx="4809744" cy="4809744"/>
           </a:xfrm>
           <a:prstGeom prst="rect">
             <a:avLst/>
@@ -30002,240 +30113,73 @@
       </p:pic>
       <p:sp>
         <p:nvSpPr>
-          <p:cNvPr id="7" name="Text 3"/>
-          <p:cNvSpPr txBox="1"/>
-          <p:nvPr/>
-        </p:nvSpPr>
-        <p:spPr>
-          <a:xfrm>
-            <a:off x="6995160" y="1508760"/>
-            <a:ext cx="4645152" cy="3432048"/>
-          </a:xfrm>
-          <a:prstGeom prst="rect">
-            <a:avLst/>
-          </a:prstGeom>
-          <a:noFill/>
-          <a:ln/>
-        </p:spPr>
-        <p:txBody>
-          <a:bodyPr wrap="square" lIns="0" tIns="0" rIns="0" bIns="0" rtlCol="0" anchor="t"/>
-          <a:lstStyle/>
-          <a:p>
-            <a:pPr indent="0" marL="0">
-              <a:spcAft>
-                <a:spcPts val="1000"/>
-              </a:spcAft>
-              <a:buNone/>
-            </a:pPr>
-            <a:r>
-              <a:rPr lang="en-US" sz="2000" dirty="0">
-                <a:solidFill>
-                  <a:schemeClr val="tx1"/>
-                </a:solidFill>
-              </a:rPr>
-              <a:t>Ce dialogue est votre porte d’entrée : il contient les </a:t>
-            </a:r>
-            <a:r>
-              <a:rPr lang="en-US" sz="2000" b="1" dirty="0">
-                <a:solidFill>
-                  <a:schemeClr val="tx1"/>
-                </a:solidFill>
-              </a:rPr>
-              <a:t>quatre piliers</a:t>
-            </a:r>
-            <a:r>
-              <a:rPr lang="en-US" sz="2000" dirty="0">
-                <a:solidFill>
-                  <a:schemeClr val="tx1"/>
-                </a:solidFill>
-              </a:rPr>
-              <a:t> de toute interaction sociale.</a:t>
-            </a:r>
-            <a:endParaRPr lang="en-US" sz="2000" dirty="0"/>
-          </a:p>
-          <a:p>
-            <a:pPr indent="0" marL="0">
-              <a:spcAft>
-                <a:spcPts val="1000"/>
-              </a:spcAft>
-              <a:buNone/>
-            </a:pPr>
-            <a:r>
-              <a:rPr lang="en-US" sz="2000" b="1" dirty="0">
-                <a:solidFill>
-                  <a:schemeClr val="tx1"/>
-                </a:solidFill>
-              </a:rPr>
-              <a:t>1</a:t>
-            </a:r>
-            <a:r>
-              <a:rPr lang="en-US" sz="2000" dirty="0">
-                <a:solidFill>
-                  <a:schemeClr val="tx1"/>
-                </a:solidFill>
-              </a:rPr>
-              <a:t> Saluer · </a:t>
-            </a:r>
-            <a:r>
-              <a:rPr lang="en-US" sz="2000" b="1" dirty="0">
-                <a:solidFill>
-                  <a:schemeClr val="tx1"/>
-                </a:solidFill>
-              </a:rPr>
-              <a:t>2</a:t>
-            </a:r>
-            <a:r>
-              <a:rPr lang="en-US" sz="2000" dirty="0">
-                <a:solidFill>
-                  <a:schemeClr val="tx1"/>
-                </a:solidFill>
-              </a:rPr>
-              <a:t> Prendre des nouvelles · </a:t>
-            </a:r>
-            <a:r>
-              <a:rPr lang="en-US" sz="2000" b="1" dirty="0">
-                <a:solidFill>
-                  <a:schemeClr val="tx1"/>
-                </a:solidFill>
-              </a:rPr>
-              <a:t>3</a:t>
-            </a:r>
-            <a:r>
-              <a:rPr lang="en-US" sz="2000" dirty="0">
-                <a:solidFill>
-                  <a:schemeClr val="tx1"/>
-                </a:solidFill>
-              </a:rPr>
-              <a:t> Être et avoir (</a:t>
-            </a:r>
-            <a:r>
-              <a:rPr lang="en-US" sz="2000" b="1" dirty="0">
-                <a:solidFill>
-                  <a:schemeClr val="tx1"/>
-                </a:solidFill>
-              </a:rPr>
-              <a:t>zijn</a:t>
-            </a:r>
-            <a:r>
-              <a:rPr lang="en-US" sz="2000" dirty="0">
-                <a:solidFill>
-                  <a:schemeClr val="tx1"/>
-                </a:solidFill>
-              </a:rPr>
-              <a:t> &amp; </a:t>
-            </a:r>
-            <a:r>
-              <a:rPr lang="en-US" sz="2000" b="1" dirty="0">
-                <a:solidFill>
-                  <a:schemeClr val="tx1"/>
-                </a:solidFill>
-              </a:rPr>
-              <a:t>hebben</a:t>
-            </a:r>
-            <a:r>
-              <a:rPr lang="en-US" sz="2000" dirty="0">
-                <a:solidFill>
-                  <a:schemeClr val="tx1"/>
-                </a:solidFill>
-              </a:rPr>
-              <a:t>) · </a:t>
-            </a:r>
-            <a:r>
-              <a:rPr lang="en-US" sz="2000" b="1" dirty="0">
-                <a:solidFill>
-                  <a:schemeClr val="tx1"/>
-                </a:solidFill>
-              </a:rPr>
-              <a:t>4</a:t>
-            </a:r>
-            <a:r>
-              <a:rPr lang="en-US" sz="2000" dirty="0">
-                <a:solidFill>
-                  <a:schemeClr val="tx1"/>
-                </a:solidFill>
-              </a:rPr>
-              <a:t> Prendre congé.</a:t>
-            </a:r>
-            <a:endParaRPr lang="en-US" sz="2000" dirty="0"/>
-          </a:p>
-          <a:p>
-            <a:pPr indent="0" marL="0">
-              <a:spcAft>
-                <a:spcPts val="1000"/>
-              </a:spcAft>
-              <a:buNone/>
-            </a:pPr>
-            <a:r>
-              <a:rPr lang="en-US" sz="2000" dirty="0">
-                <a:solidFill>
-                  <a:schemeClr val="tx1"/>
-                </a:solidFill>
-              </a:rPr>
-              <a:t>Le dialogue est découpé en </a:t>
-            </a:r>
-            <a:r>
-              <a:rPr lang="en-US" sz="2000" b="1" dirty="0">
-                <a:solidFill>
-                  <a:schemeClr val="tx1"/>
-                </a:solidFill>
-              </a:rPr>
-              <a:t>quatre séquences</a:t>
-            </a:r>
-            <a:r>
-              <a:rPr lang="en-US" sz="2000" dirty="0">
-                <a:solidFill>
-                  <a:schemeClr val="tx1"/>
-                </a:solidFill>
-              </a:rPr>
-              <a:t> : un extrait, une règle, un exercice.</a:t>
-            </a:r>
-            <a:endParaRPr lang="en-US" sz="2000" dirty="0"/>
-          </a:p>
-        </p:txBody>
-      </p:sp>
-      <p:sp>
-        <p:nvSpPr>
-          <p:cNvPr id="8" name="Shape 4"/>
+          <p:cNvPr id="7" name="aside"/>
           <p:cNvSpPr/>
           <p:nvPr/>
         </p:nvSpPr>
         <p:spPr>
           <a:xfrm>
-            <a:off x="6995160" y="5123688"/>
-            <a:ext cx="4645152" cy="1167384"/>
+            <a:off x="5678424" y="1481328"/>
+            <a:ext cx="5961888" cy="4809744"/>
           </a:xfrm>
           <a:prstGeom prst="roundRect">
             <a:avLst>
-              <a:gd name="adj" fmla="val 6266"/>
+              <a:gd name="adj" fmla="val 1521"/>
             </a:avLst>
           </a:prstGeom>
           <a:solidFill>
             <a:schemeClr val="accent1">
-              <a:alpha val="12000"/>
+              <a:alpha val="10000"/>
             </a:schemeClr>
           </a:solidFill>
           <a:ln w="12700">
             <a:solidFill>
-              <a:srgbClr val="D9700F"/>
+              <a:schemeClr val="accent1">
+                <a:alpha val="60000"/>
+              </a:schemeClr>
             </a:solidFill>
             <a:prstDash val="solid"/>
           </a:ln>
         </p:spPr>
       </p:sp>
-      <p:sp>
-        <p:nvSpPr>
-          <p:cNvPr id="9" name="Text 5"/>
-          <p:cNvSpPr txBox="1"/>
-          <p:nvPr/>
-        </p:nvSpPr>
-        <p:spPr>
-          <a:xfrm>
-            <a:off x="7178040" y="5215128"/>
-            <a:ext cx="4279392" cy="292608"/>
+      <p:pic>
+        <p:nvPicPr>
+          <p:cNvPr id="8" name="Image 1" descr="preencoded.png">    </p:cNvPr>
+          <p:cNvPicPr>
+            <a:picLocks noChangeAspect="1"/>
+          </p:cNvPicPr>
+          <p:nvPr/>
+        </p:nvPicPr>
+        <p:blipFill>
+          <a:blip r:embed="rId2"/>
+          <a:stretch>
+            <a:fillRect/>
+          </a:stretch>
+        </p:blipFill>
+        <p:spPr>
+          <a:xfrm>
+            <a:off x="5861304" y="1664208"/>
+            <a:ext cx="292608" cy="292608"/>
           </a:xfrm>
           <a:prstGeom prst="rect">
             <a:avLst/>
           </a:prstGeom>
+        </p:spPr>
+      </p:pic>
+      <p:sp>
+        <p:nvSpPr>
+          <p:cNvPr id="9" name="Text 4"/>
+          <p:cNvSpPr txBox="1"/>
+          <p:nvPr/>
+        </p:nvSpPr>
+        <p:spPr>
+          <a:xfrm>
+            <a:off x="6245352" y="1636776"/>
+            <a:ext cx="5230368" cy="347472"/>
+          </a:xfrm>
+          <a:prstGeom prst="rect">
+            <a:avLst/>
+          </a:prstGeom>
           <a:noFill/>
           <a:ln/>
         </p:spPr>
@@ -30247,27 +30191,27 @@
               <a:buNone/>
             </a:pPr>
             <a:r>
-              <a:rPr lang="en-US" sz="1200" b="1" spc="100" kern="0" dirty="0">
+              <a:rPr lang="en-US" sz="1400" b="1" spc="100" kern="0" dirty="0">
                 <a:solidFill>
                   <a:schemeClr val="accent1"/>
                 </a:solidFill>
               </a:rPr>
-              <a:t>QUESTION À LA CLASSE</a:t>
-            </a:r>
-            <a:endParaRPr lang="en-US" sz="1200" dirty="0"/>
-          </a:p>
-        </p:txBody>
-      </p:sp>
-      <p:sp>
-        <p:nvSpPr>
-          <p:cNvPr id="10" name="Text 6"/>
+              <a:t>EMMA &amp; PIETER : UN TANDEM</a:t>
+            </a:r>
+            <a:endParaRPr lang="en-US" sz="1400" dirty="0"/>
+          </a:p>
+        </p:txBody>
+      </p:sp>
+      <p:sp>
+        <p:nvSpPr>
+          <p:cNvPr id="10" name="Text 5"/>
           <p:cNvSpPr txBox="1"/>
           <p:nvPr/>
         </p:nvSpPr>
         <p:spPr>
           <a:xfrm>
-            <a:off x="7178040" y="5507736"/>
-            <a:ext cx="4279392" cy="710184"/>
+            <a:off x="5843016" y="2075688"/>
+            <a:ext cx="5632704" cy="4078224"/>
           </a:xfrm>
           <a:prstGeom prst="rect">
             <a:avLst/>
@@ -30279,18 +30223,150 @@
           <a:bodyPr wrap="square" lIns="0" tIns="0" rIns="0" bIns="0" rtlCol="0" anchor="t"/>
           <a:lstStyle/>
           <a:p>
-            <a:pPr indent="0" marL="0">
-              <a:buNone/>
-            </a:pPr>
-            <a:r>
-              <a:rPr lang="en-US" sz="1700" dirty="0">
+            <a:pPr marL="177800" indent="-177800">
+              <a:spcAft>
+                <a:spcPts val="600"/>
+              </a:spcAft>
+              <a:buSzPct val="100000"/>
+              <a:buChar char="•"/>
+            </a:pPr>
+            <a:r>
+              <a:rPr lang="en-US" sz="1800" b="1" dirty="0">
                 <a:solidFill>
                   <a:schemeClr val="tx1"/>
                 </a:solidFill>
               </a:rPr>
-              <a:t>Regardez l’image : qui sont-ils, où sont-ils, que se disent-ils ?</a:t>
-            </a:r>
-            <a:endParaRPr lang="en-US" sz="1700" dirty="0"/>
+              <a:t>Emma</a:t>
+            </a:r>
+            <a:r>
+              <a:rPr lang="en-US" sz="1800" dirty="0">
+                <a:solidFill>
+                  <a:schemeClr val="tx1"/>
+                </a:solidFill>
+              </a:rPr>
+              <a:t> : Bergen, studente, ze leert Nederlands, ze heeft een broer.</a:t>
+            </a:r>
+            <a:endParaRPr lang="en-US" sz="1800" dirty="0"/>
+          </a:p>
+          <a:p>
+            <a:pPr marL="177800" indent="-177800">
+              <a:spcAft>
+                <a:spcPts val="600"/>
+              </a:spcAft>
+              <a:buSzPct val="100000"/>
+              <a:buChar char="•"/>
+            </a:pPr>
+            <a:r>
+              <a:rPr lang="en-US" sz="1800" b="1" dirty="0">
+                <a:solidFill>
+                  <a:schemeClr val="tx1"/>
+                </a:solidFill>
+              </a:rPr>
+              <a:t>Pieter</a:t>
+            </a:r>
+            <a:r>
+              <a:rPr lang="en-US" sz="1800" dirty="0">
+                <a:solidFill>
+                  <a:schemeClr val="tx1"/>
+                </a:solidFill>
+              </a:rPr>
+              <a:t> : uit Nederland, stagiair op een school in België, hij heeft een zus.</a:t>
+            </a:r>
+            <a:endParaRPr lang="en-US" sz="1800" dirty="0"/>
+          </a:p>
+          <a:p>
+            <a:pPr marL="177800" indent="-177800">
+              <a:spcAft>
+                <a:spcPts val="600"/>
+              </a:spcAft>
+              <a:buSzPct val="100000"/>
+              <a:buChar char="•"/>
+            </a:pPr>
+            <a:r>
+              <a:rPr lang="en-US" sz="1800" b="1" dirty="0">
+                <a:solidFill>
+                  <a:schemeClr val="tx1"/>
+                </a:solidFill>
+              </a:rPr>
+              <a:t>Sarah</a:t>
+            </a:r>
+            <a:r>
+              <a:rPr lang="en-US" sz="1800" dirty="0">
+                <a:solidFill>
+                  <a:schemeClr val="tx1"/>
+                </a:solidFill>
+              </a:rPr>
+              <a:t> : Gent, collega van Pieter op school, ze heeft kinderen.</a:t>
+            </a:r>
+            <a:endParaRPr lang="en-US" sz="1800" dirty="0"/>
+          </a:p>
+          <a:p>
+            <a:pPr marL="177800" indent="-177800">
+              <a:spcAft>
+                <a:spcPts val="600"/>
+              </a:spcAft>
+              <a:buSzPct val="100000"/>
+              <a:buChar char="•"/>
+            </a:pPr>
+            <a:r>
+              <a:rPr lang="en-US" sz="1800" b="1" dirty="0">
+                <a:solidFill>
+                  <a:schemeClr val="tx1"/>
+                </a:solidFill>
+              </a:rPr>
+              <a:t>Meneer Janssens</a:t>
+            </a:r>
+            <a:r>
+              <a:rPr lang="en-US" sz="1800" dirty="0">
+                <a:solidFill>
+                  <a:schemeClr val="tx1"/>
+                </a:solidFill>
+              </a:rPr>
+              <a:t> : stagebegeleider van Pieter — Pieter zegt </a:t>
+            </a:r>
+            <a:r>
+              <a:rPr lang="en-US" sz="1800" b="1" dirty="0">
+                <a:solidFill>
+                  <a:schemeClr val="tx1"/>
+                </a:solidFill>
+              </a:rPr>
+              <a:t>u</a:t>
+            </a:r>
+            <a:r>
+              <a:rPr lang="en-US" sz="1800" dirty="0">
+                <a:solidFill>
+                  <a:schemeClr val="tx1"/>
+                </a:solidFill>
+              </a:rPr>
+              <a:t> tegen hem.</a:t>
+            </a:r>
+            <a:endParaRPr lang="en-US" sz="1800" dirty="0"/>
+          </a:p>
+          <a:p>
+            <a:pPr marL="177800" indent="-177800">
+              <a:spcAft>
+                <a:spcPts val="600"/>
+              </a:spcAft>
+              <a:buSzPct val="100000"/>
+              <a:buChar char="•"/>
+            </a:pPr>
+            <a:r>
+              <a:rPr lang="en-US" sz="1800" b="1" dirty="0">
+                <a:solidFill>
+                  <a:schemeClr val="tx1"/>
+                </a:solidFill>
+              </a:rPr>
+              <a:t>Tandem</a:t>
+            </a:r>
+            <a:r>
+              <a:rPr lang="en-US" sz="1800" dirty="0">
+                <a:solidFill>
+                  <a:schemeClr val="tx1"/>
+                </a:solidFill>
+              </a:rPr>
+              <a:t> : Emma helpt Pieter met zijn Frans, Pieter helpt Emma met haar Nederlands.</a:t>
+            </a:r>
+            <a:endParaRPr lang="en-US" sz="1800" dirty="0"/>
           </a:p>
         </p:txBody>
       </p:sp>
@@ -30982,7 +31058,7 @@
                   <a:schemeClr val="tx1"/>
                 </a:solidFill>
               </a:rPr>
-              <a:t> : lignes 3–7</a:t>
+              <a:t> : lignes 5–7</a:t>
             </a:r>
             <a:endParaRPr lang="en-US" sz="1800" dirty="0"/>
           </a:p>
@@ -31440,7 +31516,7 @@
                   <a:schemeClr val="tx1"/>
                 </a:solidFill>
               </a:rPr>
-              <a:t>Ze zeggen «Tot morgen!». → </a:t>
+              <a:t>Ze zeggen «Tot morgen!» → </a:t>
             </a:r>
             <a:r>
               <a:rPr lang="en-US" sz="2400" dirty="0">

</xml_diff>

<commit_message>
Néerlandais 2: build the 19 session decks
All 19 decks built from the session files (validation passes), with a
README listing sessions, booklet pages, review status and booklet typos.

Co-Authored-By: Claude Opus 5.5 <noreply@anthropic.com>
Claude-Session: https://claude.ai/code/session_01MyRQMehgXGGdXneVX6jxb4
</commit_message>
<xml_diff>
--- a/neerlandais2/powerpoints/Seance_01_Kennismaking_Goedemorgen.pptx
+++ b/neerlandais2/powerpoints/Seance_01_Kennismaking_Goedemorgen.pptx
@@ -132,7 +132,7 @@
   <p:extLst>
     <p:ext uri="{521415D9-36F7-43E2-AB2F-B90AF26B5E84}">
       <p14:sectionLst xmlns:p14="http://schemas.microsoft.com/office/powerpoint/2010/main">
-        <p14:section name="Ouverture" id="{e15c983a-42c5-ad6a-50a4-8877b2daf541}">
+        <p14:section name="Ouverture" id="{7c13d990-fb7b-9b4c-8641-9d57978c7971}">
           <p14:sldIdLst>
             <p14:sldId id="256"/>
             <p14:sldId id="257"/>
@@ -161,7 +161,7 @@
             <p14:sldId id="280"/>
           </p14:sldIdLst>
         </p14:section>
-        <p14:section name="Clôture" id="{d5b94644-9380-ac4d-fe94-54d00d3b6dc3}">
+        <p14:section name="Clôture" id="{b91e1b52-3d39-7615-d5d0-c271db1a6942}">
           <p14:sldIdLst>
             <p14:sldId id="281"/>
           </p14:sldIdLst>

</xml_diff>